<commit_message>
Complete the PPT for proper workflow after squash merge
</commit_message>
<xml_diff>
--- a/GitGuide_WorkFlowChart.pptx
+++ b/GitGuide_WorkFlowChart.pptx
@@ -5,12 +5,14 @@
     <p:sldMasterId id="2147483660" r:id="rId1"/>
   </p:sldMasterIdLst>
   <p:notesMasterIdLst>
-    <p:notesMasterId r:id="rId5"/>
+    <p:notesMasterId r:id="rId7"/>
   </p:notesMasterIdLst>
   <p:sldIdLst>
     <p:sldId id="256" r:id="rId2"/>
     <p:sldId id="257" r:id="rId3"/>
-    <p:sldId id="258" r:id="rId4"/>
+    <p:sldId id="260" r:id="rId4"/>
+    <p:sldId id="259" r:id="rId5"/>
+    <p:sldId id="258" r:id="rId6"/>
   </p:sldIdLst>
   <p:sldSz cx="16459200" cy="9144000"/>
   <p:notesSz cx="6858000" cy="9144000"/>
@@ -199,7 +201,7 @@
           <a:p>
             <a:fld id="{7AFB6693-90BA-4C8C-A633-111A16C466C0}" type="datetimeFigureOut">
               <a:rPr lang="en-US" smtClean="0"/>
-              <a:t>4/17/2026</a:t>
+              <a:t>4/20/2026</a:t>
             </a:fld>
             <a:endParaRPr lang="en-US"/>
           </a:p>
@@ -562,6 +564,126 @@
 </p:notes>
 </file>
 
+<file path=ppt/notesSlides/notesSlide2.xml><?xml version="1.0" encoding="utf-8"?>
+<p:notes xmlns:a="http://schemas.openxmlformats.org/drawingml/2006/main" xmlns:r="http://schemas.openxmlformats.org/officeDocument/2006/relationships" xmlns:p="http://schemas.openxmlformats.org/presentationml/2006/main">
+  <p:cSld>
+    <p:spTree>
+      <p:nvGrpSpPr>
+        <p:cNvPr id="1" name="">
+          <a:extLst>
+            <a:ext uri="{FF2B5EF4-FFF2-40B4-BE49-F238E27FC236}">
+              <a16:creationId xmlns:a16="http://schemas.microsoft.com/office/drawing/2014/main" id="{AF024D91-248E-55C0-7530-DA4885418DCC}"/>
+            </a:ext>
+          </a:extLst>
+        </p:cNvPr>
+        <p:cNvGrpSpPr/>
+        <p:nvPr/>
+      </p:nvGrpSpPr>
+      <p:grpSpPr>
+        <a:xfrm>
+          <a:off x="0" y="0"/>
+          <a:ext cx="0" cy="0"/>
+          <a:chOff x="0" y="0"/>
+          <a:chExt cx="0" cy="0"/>
+        </a:xfrm>
+      </p:grpSpPr>
+      <p:sp>
+        <p:nvSpPr>
+          <p:cNvPr id="2" name="Slide Image Placeholder 1">
+            <a:extLst>
+              <a:ext uri="{FF2B5EF4-FFF2-40B4-BE49-F238E27FC236}">
+                <a16:creationId xmlns:a16="http://schemas.microsoft.com/office/drawing/2014/main" id="{30D9E8F3-4204-957D-492D-F85AFE9EBFCB}"/>
+              </a:ext>
+            </a:extLst>
+          </p:cNvPr>
+          <p:cNvSpPr>
+            <a:spLocks noGrp="1" noRot="1" noChangeAspect="1"/>
+          </p:cNvSpPr>
+          <p:nvPr>
+            <p:ph type="sldImg"/>
+          </p:nvPr>
+        </p:nvSpPr>
+        <p:spPr>
+          <a:xfrm>
+            <a:off x="652463" y="1143000"/>
+            <a:ext cx="5553075" cy="3086100"/>
+          </a:xfrm>
+        </p:spPr>
+        <p:txBody>
+          <a:bodyPr/>
+          <a:lstStyle/>
+          <a:p>
+            <a:endParaRPr lang="en-US"/>
+          </a:p>
+        </p:txBody>
+      </p:sp>
+      <p:sp>
+        <p:nvSpPr>
+          <p:cNvPr id="3" name="Notes Placeholder 2">
+            <a:extLst>
+              <a:ext uri="{FF2B5EF4-FFF2-40B4-BE49-F238E27FC236}">
+                <a16:creationId xmlns:a16="http://schemas.microsoft.com/office/drawing/2014/main" id="{0A2322D1-2D05-76DC-3276-D280AA5E116E}"/>
+              </a:ext>
+            </a:extLst>
+          </p:cNvPr>
+          <p:cNvSpPr>
+            <a:spLocks noGrp="1"/>
+          </p:cNvSpPr>
+          <p:nvPr>
+            <p:ph type="body" idx="1"/>
+          </p:nvPr>
+        </p:nvSpPr>
+        <p:spPr/>
+        <p:txBody>
+          <a:bodyPr/>
+          <a:lstStyle/>
+          <a:p>
+            <a:endParaRPr lang="en-US" dirty="0"/>
+          </a:p>
+        </p:txBody>
+      </p:sp>
+      <p:sp>
+        <p:nvSpPr>
+          <p:cNvPr id="4" name="Slide Number Placeholder 3">
+            <a:extLst>
+              <a:ext uri="{FF2B5EF4-FFF2-40B4-BE49-F238E27FC236}">
+                <a16:creationId xmlns:a16="http://schemas.microsoft.com/office/drawing/2014/main" id="{FD4812B5-4F47-17B2-95C5-84DDAE753306}"/>
+              </a:ext>
+            </a:extLst>
+          </p:cNvPr>
+          <p:cNvSpPr>
+            <a:spLocks noGrp="1"/>
+          </p:cNvSpPr>
+          <p:nvPr>
+            <p:ph type="sldNum" sz="quarter" idx="5"/>
+          </p:nvPr>
+        </p:nvSpPr>
+        <p:spPr/>
+        <p:txBody>
+          <a:bodyPr/>
+          <a:lstStyle/>
+          <a:p>
+            <a:fld id="{6E1AF2CE-5393-4CF7-918F-03DA7A602E67}" type="slidenum">
+              <a:rPr lang="en-US" smtClean="0"/>
+              <a:t>3</a:t>
+            </a:fld>
+            <a:endParaRPr lang="en-US"/>
+          </a:p>
+        </p:txBody>
+      </p:sp>
+    </p:spTree>
+    <p:extLst>
+      <p:ext uri="{BB962C8B-B14F-4D97-AF65-F5344CB8AC3E}">
+        <p14:creationId xmlns:p14="http://schemas.microsoft.com/office/powerpoint/2010/main" val="670812740"/>
+      </p:ext>
+    </p:extLst>
+  </p:cSld>
+  <p:clrMapOvr>
+    <a:masterClrMapping/>
+  </p:clrMapOvr>
+</p:notes>
+</file>
+
 <file path=ppt/slideLayouts/slideLayout1.xml><?xml version="1.0" encoding="utf-8"?>
 <p:sldLayout xmlns:a="http://schemas.openxmlformats.org/drawingml/2006/main" xmlns:r="http://schemas.openxmlformats.org/officeDocument/2006/relationships" xmlns:p="http://schemas.openxmlformats.org/presentationml/2006/main" type="title" preserve="1">
   <p:cSld name="Title Slide">
@@ -693,7 +815,7 @@
           <a:p>
             <a:fld id="{659A64A8-8B6E-4B03-ADC8-C791F8FADDB9}" type="datetimeFigureOut">
               <a:rPr lang="en-US" smtClean="0"/>
-              <a:t>4/17/2026</a:t>
+              <a:t>4/20/2026</a:t>
             </a:fld>
             <a:endParaRPr lang="en-US"/>
           </a:p>
@@ -863,7 +985,7 @@
           <a:p>
             <a:fld id="{659A64A8-8B6E-4B03-ADC8-C791F8FADDB9}" type="datetimeFigureOut">
               <a:rPr lang="en-US" smtClean="0"/>
-              <a:t>4/17/2026</a:t>
+              <a:t>4/20/2026</a:t>
             </a:fld>
             <a:endParaRPr lang="en-US"/>
           </a:p>
@@ -1043,7 +1165,7 @@
           <a:p>
             <a:fld id="{659A64A8-8B6E-4B03-ADC8-C791F8FADDB9}" type="datetimeFigureOut">
               <a:rPr lang="en-US" smtClean="0"/>
-              <a:t>4/17/2026</a:t>
+              <a:t>4/20/2026</a:t>
             </a:fld>
             <a:endParaRPr lang="en-US"/>
           </a:p>
@@ -1213,7 +1335,7 @@
           <a:p>
             <a:fld id="{659A64A8-8B6E-4B03-ADC8-C791F8FADDB9}" type="datetimeFigureOut">
               <a:rPr lang="en-US" smtClean="0"/>
-              <a:t>4/17/2026</a:t>
+              <a:t>4/20/2026</a:t>
             </a:fld>
             <a:endParaRPr lang="en-US"/>
           </a:p>
@@ -1459,7 +1581,7 @@
           <a:p>
             <a:fld id="{659A64A8-8B6E-4B03-ADC8-C791F8FADDB9}" type="datetimeFigureOut">
               <a:rPr lang="en-US" smtClean="0"/>
-              <a:t>4/17/2026</a:t>
+              <a:t>4/20/2026</a:t>
             </a:fld>
             <a:endParaRPr lang="en-US"/>
           </a:p>
@@ -1691,7 +1813,7 @@
           <a:p>
             <a:fld id="{659A64A8-8B6E-4B03-ADC8-C791F8FADDB9}" type="datetimeFigureOut">
               <a:rPr lang="en-US" smtClean="0"/>
-              <a:t>4/17/2026</a:t>
+              <a:t>4/20/2026</a:t>
             </a:fld>
             <a:endParaRPr lang="en-US"/>
           </a:p>
@@ -2058,7 +2180,7 @@
           <a:p>
             <a:fld id="{659A64A8-8B6E-4B03-ADC8-C791F8FADDB9}" type="datetimeFigureOut">
               <a:rPr lang="en-US" smtClean="0"/>
-              <a:t>4/17/2026</a:t>
+              <a:t>4/20/2026</a:t>
             </a:fld>
             <a:endParaRPr lang="en-US"/>
           </a:p>
@@ -2176,7 +2298,7 @@
           <a:p>
             <a:fld id="{659A64A8-8B6E-4B03-ADC8-C791F8FADDB9}" type="datetimeFigureOut">
               <a:rPr lang="en-US" smtClean="0"/>
-              <a:t>4/17/2026</a:t>
+              <a:t>4/20/2026</a:t>
             </a:fld>
             <a:endParaRPr lang="en-US"/>
           </a:p>
@@ -2271,7 +2393,7 @@
           <a:p>
             <a:fld id="{659A64A8-8B6E-4B03-ADC8-C791F8FADDB9}" type="datetimeFigureOut">
               <a:rPr lang="en-US" smtClean="0"/>
-              <a:t>4/17/2026</a:t>
+              <a:t>4/20/2026</a:t>
             </a:fld>
             <a:endParaRPr lang="en-US"/>
           </a:p>
@@ -2548,7 +2670,7 @@
           <a:p>
             <a:fld id="{659A64A8-8B6E-4B03-ADC8-C791F8FADDB9}" type="datetimeFigureOut">
               <a:rPr lang="en-US" smtClean="0"/>
-              <a:t>4/17/2026</a:t>
+              <a:t>4/20/2026</a:t>
             </a:fld>
             <a:endParaRPr lang="en-US"/>
           </a:p>
@@ -2805,7 +2927,7 @@
           <a:p>
             <a:fld id="{659A64A8-8B6E-4B03-ADC8-C791F8FADDB9}" type="datetimeFigureOut">
               <a:rPr lang="en-US" smtClean="0"/>
-              <a:t>4/17/2026</a:t>
+              <a:t>4/20/2026</a:t>
             </a:fld>
             <a:endParaRPr lang="en-US"/>
           </a:p>
@@ -3018,7 +3140,7 @@
           <a:p>
             <a:fld id="{659A64A8-8B6E-4B03-ADC8-C791F8FADDB9}" type="datetimeFigureOut">
               <a:rPr lang="en-US" smtClean="0"/>
-              <a:t>4/17/2026</a:t>
+              <a:t>4/20/2026</a:t>
             </a:fld>
             <a:endParaRPr lang="en-US"/>
           </a:p>
@@ -6964,8 +7086,8 @@
         </p:blipFill>
         <p:spPr>
           <a:xfrm>
-            <a:off x="487200" y="327212"/>
-            <a:ext cx="5720536" cy="8489576"/>
+            <a:off x="93500" y="327212"/>
+            <a:ext cx="5128045" cy="7610288"/>
           </a:xfrm>
           <a:prstGeom prst="rect">
             <a:avLst/>
@@ -7004,10 +7126,10 @@
       </p:pic>
       <p:pic>
         <p:nvPicPr>
-          <p:cNvPr id="9" name="Picture 8">
+          <p:cNvPr id="3" name="Picture 2">
             <a:extLst>
               <a:ext uri="{FF2B5EF4-FFF2-40B4-BE49-F238E27FC236}">
-                <a16:creationId xmlns:a16="http://schemas.microsoft.com/office/drawing/2014/main" id="{C9623670-1B4A-CD4C-393C-42264E37810E}"/>
+                <a16:creationId xmlns:a16="http://schemas.microsoft.com/office/drawing/2014/main" id="{5435DB6B-918C-3E6B-1E2E-FC1A30713FCD}"/>
               </a:ext>
             </a:extLst>
           </p:cNvPr>
@@ -7024,8 +7146,8 @@
         </p:blipFill>
         <p:spPr>
           <a:xfrm>
-            <a:off x="7035282" y="400013"/>
-            <a:ext cx="6432367" cy="8343973"/>
+            <a:off x="10762044" y="327212"/>
+            <a:ext cx="5172278" cy="7610288"/>
           </a:xfrm>
           <a:prstGeom prst="rect">
             <a:avLst/>
@@ -7062,6 +7184,66 @@
           </a:sp3d>
         </p:spPr>
       </p:pic>
+      <p:pic>
+        <p:nvPicPr>
+          <p:cNvPr id="5" name="Picture 4">
+            <a:extLst>
+              <a:ext uri="{FF2B5EF4-FFF2-40B4-BE49-F238E27FC236}">
+                <a16:creationId xmlns:a16="http://schemas.microsoft.com/office/drawing/2014/main" id="{F3D9CA35-475B-4D7C-2921-852CA61A22BE}"/>
+              </a:ext>
+            </a:extLst>
+          </p:cNvPr>
+          <p:cNvPicPr>
+            <a:picLocks noChangeAspect="1"/>
+          </p:cNvPicPr>
+          <p:nvPr/>
+        </p:nvPicPr>
+        <p:blipFill>
+          <a:blip r:embed="rId4"/>
+          <a:stretch>
+            <a:fillRect/>
+          </a:stretch>
+        </p:blipFill>
+        <p:spPr>
+          <a:xfrm>
+            <a:off x="5557504" y="266700"/>
+            <a:ext cx="4868581" cy="7610288"/>
+          </a:xfrm>
+          <a:prstGeom prst="rect">
+            <a:avLst/>
+          </a:prstGeom>
+          <a:solidFill>
+            <a:srgbClr val="FFFFFF">
+              <a:shade val="85000"/>
+            </a:srgbClr>
+          </a:solidFill>
+          <a:ln w="88900" cap="sq">
+            <a:solidFill>
+              <a:srgbClr val="FFFFFF"/>
+            </a:solidFill>
+            <a:miter lim="800000"/>
+          </a:ln>
+          <a:effectLst>
+            <a:outerShdw blurRad="55000" dist="18000" dir="5400000" algn="tl" rotWithShape="0">
+              <a:srgbClr val="000000">
+                <a:alpha val="40000"/>
+              </a:srgbClr>
+            </a:outerShdw>
+          </a:effectLst>
+          <a:scene3d>
+            <a:camera prst="orthographicFront"/>
+            <a:lightRig rig="twoPt" dir="t">
+              <a:rot lat="0" lon="0" rev="7200000"/>
+            </a:lightRig>
+          </a:scene3d>
+          <a:sp3d>
+            <a:bevelT w="25400" h="19050"/>
+            <a:contourClr>
+              <a:srgbClr val="FFFFFF"/>
+            </a:contourClr>
+          </a:sp3d>
+        </p:spPr>
+      </p:pic>
     </p:spTree>
     <p:extLst>
       <p:ext uri="{BB962C8B-B14F-4D97-AF65-F5344CB8AC3E}">
@@ -7076,6 +7258,4150 @@
 </file>
 
 <file path=ppt/slides/slide3.xml><?xml version="1.0" encoding="utf-8"?>
+<p:sld xmlns:a="http://schemas.openxmlformats.org/drawingml/2006/main" xmlns:r="http://schemas.openxmlformats.org/officeDocument/2006/relationships" xmlns:p="http://schemas.openxmlformats.org/presentationml/2006/main">
+  <p:cSld>
+    <p:spTree>
+      <p:nvGrpSpPr>
+        <p:cNvPr id="1" name="">
+          <a:extLst>
+            <a:ext uri="{FF2B5EF4-FFF2-40B4-BE49-F238E27FC236}">
+              <a16:creationId xmlns:a16="http://schemas.microsoft.com/office/drawing/2014/main" id="{2E7BE16E-19D5-B1BA-51B5-F2AD02944684}"/>
+            </a:ext>
+          </a:extLst>
+        </p:cNvPr>
+        <p:cNvGrpSpPr/>
+        <p:nvPr/>
+      </p:nvGrpSpPr>
+      <p:grpSpPr>
+        <a:xfrm>
+          <a:off x="0" y="0"/>
+          <a:ext cx="0" cy="0"/>
+          <a:chOff x="0" y="0"/>
+          <a:chExt cx="0" cy="0"/>
+        </a:xfrm>
+      </p:grpSpPr>
+      <p:cxnSp>
+        <p:nvCxnSpPr>
+          <p:cNvPr id="82" name="Straight Connector 81">
+            <a:extLst>
+              <a:ext uri="{FF2B5EF4-FFF2-40B4-BE49-F238E27FC236}">
+                <a16:creationId xmlns:a16="http://schemas.microsoft.com/office/drawing/2014/main" id="{E67BFC08-EB4E-CC47-8D31-F0B6ACE3418A}"/>
+              </a:ext>
+            </a:extLst>
+          </p:cNvPr>
+          <p:cNvCxnSpPr>
+            <a:cxnSpLocks/>
+          </p:cNvCxnSpPr>
+          <p:nvPr/>
+        </p:nvCxnSpPr>
+        <p:spPr>
+          <a:xfrm>
+            <a:off x="12596554" y="6457339"/>
+            <a:ext cx="2798039" cy="0"/>
+          </a:xfrm>
+          <a:prstGeom prst="line">
+            <a:avLst/>
+          </a:prstGeom>
+          <a:ln w="76200">
+            <a:solidFill>
+              <a:schemeClr val="accent1">
+                <a:alpha val="50000"/>
+              </a:schemeClr>
+            </a:solidFill>
+          </a:ln>
+        </p:spPr>
+        <p:style>
+          <a:lnRef idx="3">
+            <a:schemeClr val="accent1"/>
+          </a:lnRef>
+          <a:fillRef idx="0">
+            <a:schemeClr val="accent1"/>
+          </a:fillRef>
+          <a:effectRef idx="2">
+            <a:schemeClr val="accent1"/>
+          </a:effectRef>
+          <a:fontRef idx="minor">
+            <a:schemeClr val="tx1"/>
+          </a:fontRef>
+        </p:style>
+      </p:cxnSp>
+      <p:cxnSp>
+        <p:nvCxnSpPr>
+          <p:cNvPr id="21" name="Straight Arrow Connector 20">
+            <a:extLst>
+              <a:ext uri="{FF2B5EF4-FFF2-40B4-BE49-F238E27FC236}">
+                <a16:creationId xmlns:a16="http://schemas.microsoft.com/office/drawing/2014/main" id="{62A87109-C35F-9DCD-FB02-D83F384777B4}"/>
+              </a:ext>
+            </a:extLst>
+          </p:cNvPr>
+          <p:cNvCxnSpPr>
+            <a:cxnSpLocks/>
+            <a:endCxn id="26" idx="4"/>
+          </p:cNvCxnSpPr>
+          <p:nvPr/>
+        </p:nvCxnSpPr>
+        <p:spPr>
+          <a:xfrm flipV="1">
+            <a:off x="11499563" y="1084201"/>
+            <a:ext cx="610852" cy="1872337"/>
+          </a:xfrm>
+          <a:prstGeom prst="straightConnector1">
+            <a:avLst/>
+          </a:prstGeom>
+          <a:ln>
+            <a:solidFill>
+              <a:srgbClr val="00B0F0"/>
+            </a:solidFill>
+            <a:headEnd type="none" w="med" len="med"/>
+            <a:tailEnd type="arrow" w="med" len="med"/>
+          </a:ln>
+        </p:spPr>
+        <p:style>
+          <a:lnRef idx="3">
+            <a:schemeClr val="accent1"/>
+          </a:lnRef>
+          <a:fillRef idx="0">
+            <a:schemeClr val="accent1"/>
+          </a:fillRef>
+          <a:effectRef idx="2">
+            <a:schemeClr val="accent1"/>
+          </a:effectRef>
+          <a:fontRef idx="minor">
+            <a:schemeClr val="tx1"/>
+          </a:fontRef>
+        </p:style>
+      </p:cxnSp>
+      <p:cxnSp>
+        <p:nvCxnSpPr>
+          <p:cNvPr id="51" name="Straight Connector 50">
+            <a:extLst>
+              <a:ext uri="{FF2B5EF4-FFF2-40B4-BE49-F238E27FC236}">
+                <a16:creationId xmlns:a16="http://schemas.microsoft.com/office/drawing/2014/main" id="{FFF77E92-6FBB-19E1-0721-7472088CF2AF}"/>
+              </a:ext>
+            </a:extLst>
+          </p:cNvPr>
+          <p:cNvCxnSpPr>
+            <a:cxnSpLocks/>
+          </p:cNvCxnSpPr>
+          <p:nvPr/>
+        </p:nvCxnSpPr>
+        <p:spPr>
+          <a:xfrm>
+            <a:off x="11459091" y="1988200"/>
+            <a:ext cx="3586667" cy="0"/>
+          </a:xfrm>
+          <a:prstGeom prst="line">
+            <a:avLst/>
+          </a:prstGeom>
+          <a:ln w="76200">
+            <a:solidFill>
+              <a:schemeClr val="accent1">
+                <a:alpha val="20000"/>
+              </a:schemeClr>
+            </a:solidFill>
+            <a:prstDash val="sysDot"/>
+          </a:ln>
+        </p:spPr>
+        <p:style>
+          <a:lnRef idx="3">
+            <a:schemeClr val="accent1"/>
+          </a:lnRef>
+          <a:fillRef idx="0">
+            <a:schemeClr val="accent1"/>
+          </a:fillRef>
+          <a:effectRef idx="2">
+            <a:schemeClr val="accent1"/>
+          </a:effectRef>
+          <a:fontRef idx="minor">
+            <a:schemeClr val="tx1"/>
+          </a:fontRef>
+        </p:style>
+      </p:cxnSp>
+      <p:cxnSp>
+        <p:nvCxnSpPr>
+          <p:cNvPr id="13" name="Straight Arrow Connector 12">
+            <a:extLst>
+              <a:ext uri="{FF2B5EF4-FFF2-40B4-BE49-F238E27FC236}">
+                <a16:creationId xmlns:a16="http://schemas.microsoft.com/office/drawing/2014/main" id="{AA720C4B-8FCE-B995-C4CF-7D249621C4B2}"/>
+              </a:ext>
+            </a:extLst>
+          </p:cNvPr>
+          <p:cNvCxnSpPr>
+            <a:cxnSpLocks/>
+            <a:endCxn id="162" idx="2"/>
+          </p:cNvCxnSpPr>
+          <p:nvPr/>
+        </p:nvCxnSpPr>
+        <p:spPr>
+          <a:xfrm flipV="1">
+            <a:off x="4025926" y="867935"/>
+            <a:ext cx="2983919" cy="999658"/>
+          </a:xfrm>
+          <a:prstGeom prst="straightConnector1">
+            <a:avLst/>
+          </a:prstGeom>
+          <a:ln>
+            <a:solidFill>
+              <a:srgbClr val="00B0F0"/>
+            </a:solidFill>
+            <a:headEnd type="none" w="med" len="med"/>
+            <a:tailEnd type="arrow" w="med" len="med"/>
+          </a:ln>
+        </p:spPr>
+        <p:style>
+          <a:lnRef idx="3">
+            <a:schemeClr val="accent1"/>
+          </a:lnRef>
+          <a:fillRef idx="0">
+            <a:schemeClr val="accent1"/>
+          </a:fillRef>
+          <a:effectRef idx="2">
+            <a:schemeClr val="accent1"/>
+          </a:effectRef>
+          <a:fontRef idx="minor">
+            <a:schemeClr val="tx1"/>
+          </a:fontRef>
+        </p:style>
+      </p:cxnSp>
+      <p:cxnSp>
+        <p:nvCxnSpPr>
+          <p:cNvPr id="3" name="Straight Connector 2">
+            <a:extLst>
+              <a:ext uri="{FF2B5EF4-FFF2-40B4-BE49-F238E27FC236}">
+                <a16:creationId xmlns:a16="http://schemas.microsoft.com/office/drawing/2014/main" id="{E4EF5C90-BFA0-36E1-057F-EDAA3564926B}"/>
+              </a:ext>
+            </a:extLst>
+          </p:cNvPr>
+          <p:cNvCxnSpPr>
+            <a:cxnSpLocks/>
+          </p:cNvCxnSpPr>
+          <p:nvPr/>
+        </p:nvCxnSpPr>
+        <p:spPr>
+          <a:xfrm>
+            <a:off x="7160602" y="878938"/>
+            <a:ext cx="1788958" cy="0"/>
+          </a:xfrm>
+          <a:prstGeom prst="line">
+            <a:avLst/>
+          </a:prstGeom>
+          <a:ln w="76200">
+            <a:solidFill>
+              <a:schemeClr val="accent1">
+                <a:alpha val="50000"/>
+              </a:schemeClr>
+            </a:solidFill>
+          </a:ln>
+        </p:spPr>
+        <p:style>
+          <a:lnRef idx="3">
+            <a:schemeClr val="accent1"/>
+          </a:lnRef>
+          <a:fillRef idx="0">
+            <a:schemeClr val="accent1"/>
+          </a:fillRef>
+          <a:effectRef idx="2">
+            <a:schemeClr val="accent1"/>
+          </a:effectRef>
+          <a:fontRef idx="minor">
+            <a:schemeClr val="tx1"/>
+          </a:fontRef>
+        </p:style>
+      </p:cxnSp>
+      <p:sp>
+        <p:nvSpPr>
+          <p:cNvPr id="194" name="TextBox 193">
+            <a:extLst>
+              <a:ext uri="{FF2B5EF4-FFF2-40B4-BE49-F238E27FC236}">
+                <a16:creationId xmlns:a16="http://schemas.microsoft.com/office/drawing/2014/main" id="{5E763F9F-0780-3DC8-9376-A5DF4E7A0D36}"/>
+              </a:ext>
+            </a:extLst>
+          </p:cNvPr>
+          <p:cNvSpPr txBox="1"/>
+          <p:nvPr/>
+        </p:nvSpPr>
+        <p:spPr>
+          <a:xfrm rot="16200000">
+            <a:off x="2576688" y="5029080"/>
+            <a:ext cx="1846659" cy="5785382"/>
+          </a:xfrm>
+          <a:prstGeom prst="rect">
+            <a:avLst/>
+          </a:prstGeom>
+          <a:noFill/>
+        </p:spPr>
+        <p:txBody>
+          <a:bodyPr vert="eaVert" wrap="square" rtlCol="0">
+            <a:spAutoFit/>
+          </a:bodyPr>
+          <a:lstStyle/>
+          <a:p>
+            <a:r>
+              <a:rPr lang="en-US" sz="1200" dirty="0"/>
+              <a:t>The center orange-colored </a:t>
+            </a:r>
+            <a:r>
+              <a:rPr lang="en-US" sz="1200" b="1" dirty="0">
+                <a:solidFill>
+                  <a:srgbClr val="FFC000"/>
+                </a:solidFill>
+              </a:rPr>
+              <a:t>Public_GitHub </a:t>
+            </a:r>
+            <a:r>
+              <a:rPr lang="en-US" sz="1200" dirty="0"/>
+              <a:t>branch is public, everything else is private (local or in an internally managed remote, like GitLab for UM). Public can be merged into private side, but private branches must be squash merged into public.</a:t>
+            </a:r>
+          </a:p>
+          <a:p>
+            <a:endParaRPr lang="en-US" sz="1200" dirty="0"/>
+          </a:p>
+          <a:p>
+            <a:r>
+              <a:rPr lang="en-US" sz="1200" dirty="0"/>
+              <a:t>Solid line indicate parent child relationship, </a:t>
+            </a:r>
+          </a:p>
+          <a:p>
+            <a:r>
+              <a:rPr lang="en-US" sz="1200" dirty="0"/>
+              <a:t>Dotted line (only in Squash merge, which doesn’t create parent child relationship.</a:t>
+            </a:r>
+            <a:br>
+              <a:rPr lang="en-US" sz="1200" dirty="0"/>
+            </a:br>
+            <a:br>
+              <a:rPr lang="en-US" sz="1200" dirty="0"/>
+            </a:br>
+            <a:r>
+              <a:rPr lang="en-US" sz="1200" dirty="0"/>
+              <a:t>M is for typical merge</a:t>
+            </a:r>
+          </a:p>
+          <a:p>
+            <a:r>
+              <a:rPr lang="en-US" sz="1200" dirty="0"/>
+              <a:t>S is for squash merge</a:t>
+            </a:r>
+          </a:p>
+        </p:txBody>
+      </p:sp>
+      <p:cxnSp>
+        <p:nvCxnSpPr>
+          <p:cNvPr id="157" name="Straight Arrow Connector 156">
+            <a:extLst>
+              <a:ext uri="{FF2B5EF4-FFF2-40B4-BE49-F238E27FC236}">
+                <a16:creationId xmlns:a16="http://schemas.microsoft.com/office/drawing/2014/main" id="{14C41278-9F29-32CD-E288-D0C93EDDD508}"/>
+              </a:ext>
+            </a:extLst>
+          </p:cNvPr>
+          <p:cNvCxnSpPr>
+            <a:cxnSpLocks/>
+            <a:stCxn id="146" idx="0"/>
+            <a:endCxn id="163" idx="4"/>
+          </p:cNvCxnSpPr>
+          <p:nvPr/>
+        </p:nvCxnSpPr>
+        <p:spPr>
+          <a:xfrm flipV="1">
+            <a:off x="8319168" y="1105515"/>
+            <a:ext cx="630392" cy="1746356"/>
+          </a:xfrm>
+          <a:prstGeom prst="straightConnector1">
+            <a:avLst/>
+          </a:prstGeom>
+          <a:ln w="25400">
+            <a:solidFill>
+              <a:srgbClr val="00B0F0">
+                <a:alpha val="30000"/>
+              </a:srgbClr>
+            </a:solidFill>
+            <a:headEnd type="none" w="med" len="med"/>
+            <a:tailEnd type="arrow" w="med" len="med"/>
+          </a:ln>
+        </p:spPr>
+        <p:style>
+          <a:lnRef idx="3">
+            <a:schemeClr val="accent1"/>
+          </a:lnRef>
+          <a:fillRef idx="0">
+            <a:schemeClr val="accent1"/>
+          </a:fillRef>
+          <a:effectRef idx="2">
+            <a:schemeClr val="accent1"/>
+          </a:effectRef>
+          <a:fontRef idx="minor">
+            <a:schemeClr val="tx1"/>
+          </a:fontRef>
+        </p:style>
+      </p:cxnSp>
+      <p:cxnSp>
+        <p:nvCxnSpPr>
+          <p:cNvPr id="39" name="Straight Arrow Connector 38">
+            <a:extLst>
+              <a:ext uri="{FF2B5EF4-FFF2-40B4-BE49-F238E27FC236}">
+                <a16:creationId xmlns:a16="http://schemas.microsoft.com/office/drawing/2014/main" id="{F9B2393E-27A1-1FF8-B5E2-7F92CB6E9EA2}"/>
+              </a:ext>
+            </a:extLst>
+          </p:cNvPr>
+          <p:cNvCxnSpPr>
+            <a:cxnSpLocks/>
+            <a:endCxn id="50" idx="4"/>
+          </p:cNvCxnSpPr>
+          <p:nvPr/>
+        </p:nvCxnSpPr>
+        <p:spPr>
+          <a:xfrm flipH="1" flipV="1">
+            <a:off x="899364" y="1088995"/>
+            <a:ext cx="1791" cy="2297670"/>
+          </a:xfrm>
+          <a:prstGeom prst="straightConnector1">
+            <a:avLst/>
+          </a:prstGeom>
+          <a:ln>
+            <a:headEnd type="none" w="med" len="med"/>
+            <a:tailEnd type="arrow" w="med" len="med"/>
+          </a:ln>
+        </p:spPr>
+        <p:style>
+          <a:lnRef idx="3">
+            <a:schemeClr val="accent1"/>
+          </a:lnRef>
+          <a:fillRef idx="0">
+            <a:schemeClr val="accent1"/>
+          </a:fillRef>
+          <a:effectRef idx="2">
+            <a:schemeClr val="accent1"/>
+          </a:effectRef>
+          <a:fontRef idx="minor">
+            <a:schemeClr val="tx1"/>
+          </a:fontRef>
+        </p:style>
+      </p:cxnSp>
+      <p:cxnSp>
+        <p:nvCxnSpPr>
+          <p:cNvPr id="47" name="Straight Connector 46">
+            <a:extLst>
+              <a:ext uri="{FF2B5EF4-FFF2-40B4-BE49-F238E27FC236}">
+                <a16:creationId xmlns:a16="http://schemas.microsoft.com/office/drawing/2014/main" id="{DEED0EAE-2003-A44B-D2F4-C6E6481CB5D1}"/>
+              </a:ext>
+            </a:extLst>
+          </p:cNvPr>
+          <p:cNvCxnSpPr>
+            <a:cxnSpLocks/>
+          </p:cNvCxnSpPr>
+          <p:nvPr/>
+        </p:nvCxnSpPr>
+        <p:spPr>
+          <a:xfrm>
+            <a:off x="997678" y="878909"/>
+            <a:ext cx="2440326" cy="0"/>
+          </a:xfrm>
+          <a:prstGeom prst="line">
+            <a:avLst/>
+          </a:prstGeom>
+          <a:ln w="76200">
+            <a:solidFill>
+              <a:schemeClr val="accent1">
+                <a:alpha val="50000"/>
+              </a:schemeClr>
+            </a:solidFill>
+          </a:ln>
+        </p:spPr>
+        <p:style>
+          <a:lnRef idx="3">
+            <a:schemeClr val="accent1"/>
+          </a:lnRef>
+          <a:fillRef idx="0">
+            <a:schemeClr val="accent1"/>
+          </a:fillRef>
+          <a:effectRef idx="2">
+            <a:schemeClr val="accent1"/>
+          </a:effectRef>
+          <a:fontRef idx="minor">
+            <a:schemeClr val="tx1"/>
+          </a:fontRef>
+        </p:style>
+      </p:cxnSp>
+      <p:cxnSp>
+        <p:nvCxnSpPr>
+          <p:cNvPr id="30" name="Straight Connector 29">
+            <a:extLst>
+              <a:ext uri="{FF2B5EF4-FFF2-40B4-BE49-F238E27FC236}">
+                <a16:creationId xmlns:a16="http://schemas.microsoft.com/office/drawing/2014/main" id="{01D9D0EB-BCD9-0DBD-1C70-8F09F5E68180}"/>
+              </a:ext>
+            </a:extLst>
+          </p:cNvPr>
+          <p:cNvCxnSpPr>
+            <a:cxnSpLocks/>
+          </p:cNvCxnSpPr>
+          <p:nvPr/>
+        </p:nvCxnSpPr>
+        <p:spPr>
+          <a:xfrm>
+            <a:off x="1115630" y="6457339"/>
+            <a:ext cx="6907706" cy="0"/>
+          </a:xfrm>
+          <a:prstGeom prst="line">
+            <a:avLst/>
+          </a:prstGeom>
+          <a:ln w="76200">
+            <a:solidFill>
+              <a:schemeClr val="accent1">
+                <a:alpha val="50000"/>
+              </a:schemeClr>
+            </a:solidFill>
+          </a:ln>
+        </p:spPr>
+        <p:style>
+          <a:lnRef idx="3">
+            <a:schemeClr val="accent1"/>
+          </a:lnRef>
+          <a:fillRef idx="0">
+            <a:schemeClr val="accent1"/>
+          </a:fillRef>
+          <a:effectRef idx="2">
+            <a:schemeClr val="accent1"/>
+          </a:effectRef>
+          <a:fontRef idx="minor">
+            <a:schemeClr val="tx1"/>
+          </a:fontRef>
+        </p:style>
+      </p:cxnSp>
+      <p:cxnSp>
+        <p:nvCxnSpPr>
+          <p:cNvPr id="29" name="Straight Connector 28">
+            <a:extLst>
+              <a:ext uri="{FF2B5EF4-FFF2-40B4-BE49-F238E27FC236}">
+                <a16:creationId xmlns:a16="http://schemas.microsoft.com/office/drawing/2014/main" id="{FFD3C0C0-FAE4-4FE2-2EC4-5A8E20AAF0B0}"/>
+              </a:ext>
+            </a:extLst>
+          </p:cNvPr>
+          <p:cNvCxnSpPr>
+            <a:cxnSpLocks/>
+          </p:cNvCxnSpPr>
+          <p:nvPr/>
+        </p:nvCxnSpPr>
+        <p:spPr>
+          <a:xfrm>
+            <a:off x="3726165" y="1988200"/>
+            <a:ext cx="7585555" cy="0"/>
+          </a:xfrm>
+          <a:prstGeom prst="line">
+            <a:avLst/>
+          </a:prstGeom>
+          <a:ln w="76200">
+            <a:solidFill>
+              <a:schemeClr val="accent1">
+                <a:alpha val="50000"/>
+              </a:schemeClr>
+            </a:solidFill>
+          </a:ln>
+        </p:spPr>
+        <p:style>
+          <a:lnRef idx="3">
+            <a:schemeClr val="accent1"/>
+          </a:lnRef>
+          <a:fillRef idx="0">
+            <a:schemeClr val="accent1"/>
+          </a:fillRef>
+          <a:effectRef idx="2">
+            <a:schemeClr val="accent1"/>
+          </a:effectRef>
+          <a:fontRef idx="minor">
+            <a:schemeClr val="tx1"/>
+          </a:fontRef>
+        </p:style>
+      </p:cxnSp>
+      <p:cxnSp>
+        <p:nvCxnSpPr>
+          <p:cNvPr id="27" name="Straight Connector 26">
+            <a:extLst>
+              <a:ext uri="{FF2B5EF4-FFF2-40B4-BE49-F238E27FC236}">
+                <a16:creationId xmlns:a16="http://schemas.microsoft.com/office/drawing/2014/main" id="{AD57C197-8176-4D49-F1B5-C20EB1A67953}"/>
+              </a:ext>
+            </a:extLst>
+          </p:cNvPr>
+          <p:cNvCxnSpPr>
+            <a:cxnSpLocks/>
+          </p:cNvCxnSpPr>
+          <p:nvPr/>
+        </p:nvCxnSpPr>
+        <p:spPr>
+          <a:xfrm>
+            <a:off x="1029891" y="3068516"/>
+            <a:ext cx="14031788" cy="20535"/>
+          </a:xfrm>
+          <a:prstGeom prst="line">
+            <a:avLst/>
+          </a:prstGeom>
+          <a:ln w="76200">
+            <a:solidFill>
+              <a:srgbClr val="FFC000"/>
+            </a:solidFill>
+          </a:ln>
+        </p:spPr>
+        <p:style>
+          <a:lnRef idx="3">
+            <a:schemeClr val="accent1"/>
+          </a:lnRef>
+          <a:fillRef idx="0">
+            <a:schemeClr val="accent1"/>
+          </a:fillRef>
+          <a:effectRef idx="2">
+            <a:schemeClr val="accent1"/>
+          </a:effectRef>
+          <a:fontRef idx="minor">
+            <a:schemeClr val="tx1"/>
+          </a:fontRef>
+        </p:style>
+      </p:cxnSp>
+      <p:sp>
+        <p:nvSpPr>
+          <p:cNvPr id="6" name="Oval 5">
+            <a:extLst>
+              <a:ext uri="{FF2B5EF4-FFF2-40B4-BE49-F238E27FC236}">
+                <a16:creationId xmlns:a16="http://schemas.microsoft.com/office/drawing/2014/main" id="{55DC3A33-4231-DCC1-4A53-BDE866F8C15D}"/>
+              </a:ext>
+            </a:extLst>
+          </p:cNvPr>
+          <p:cNvSpPr/>
+          <p:nvPr/>
+        </p:nvSpPr>
+        <p:spPr>
+          <a:xfrm>
+            <a:off x="3625750" y="1765097"/>
+            <a:ext cx="432532" cy="432532"/>
+          </a:xfrm>
+          <a:prstGeom prst="ellipse">
+            <a:avLst/>
+          </a:prstGeom>
+        </p:spPr>
+        <p:style>
+          <a:lnRef idx="2">
+            <a:schemeClr val="dk1"/>
+          </a:lnRef>
+          <a:fillRef idx="1">
+            <a:schemeClr val="lt1"/>
+          </a:fillRef>
+          <a:effectRef idx="0">
+            <a:schemeClr val="dk1"/>
+          </a:effectRef>
+          <a:fontRef idx="minor">
+            <a:schemeClr val="dk1"/>
+          </a:fontRef>
+        </p:style>
+        <p:txBody>
+          <a:bodyPr rtlCol="0" anchor="ctr"/>
+          <a:lstStyle/>
+          <a:p>
+            <a:pPr algn="ctr"/>
+            <a:endParaRPr lang="en-US" sz="800" b="1" dirty="0"/>
+          </a:p>
+        </p:txBody>
+      </p:sp>
+      <p:sp>
+        <p:nvSpPr>
+          <p:cNvPr id="7" name="Oval 6">
+            <a:extLst>
+              <a:ext uri="{FF2B5EF4-FFF2-40B4-BE49-F238E27FC236}">
+                <a16:creationId xmlns:a16="http://schemas.microsoft.com/office/drawing/2014/main" id="{6A1A0738-22D9-AB02-DB21-FD73282431DD}"/>
+              </a:ext>
+            </a:extLst>
+          </p:cNvPr>
+          <p:cNvSpPr/>
+          <p:nvPr/>
+        </p:nvSpPr>
+        <p:spPr>
+          <a:xfrm>
+            <a:off x="2098678" y="6241073"/>
+            <a:ext cx="432532" cy="432532"/>
+          </a:xfrm>
+          <a:prstGeom prst="ellipse">
+            <a:avLst/>
+          </a:prstGeom>
+        </p:spPr>
+        <p:style>
+          <a:lnRef idx="2">
+            <a:schemeClr val="dk1"/>
+          </a:lnRef>
+          <a:fillRef idx="1">
+            <a:schemeClr val="lt1"/>
+          </a:fillRef>
+          <a:effectRef idx="0">
+            <a:schemeClr val="dk1"/>
+          </a:effectRef>
+          <a:fontRef idx="minor">
+            <a:schemeClr val="dk1"/>
+          </a:fontRef>
+        </p:style>
+        <p:txBody>
+          <a:bodyPr rtlCol="0" anchor="ctr"/>
+          <a:lstStyle/>
+          <a:p>
+            <a:pPr algn="ctr"/>
+            <a:r>
+              <a:rPr lang="en-US" sz="2000" b="1" dirty="0"/>
+              <a:t>D</a:t>
+            </a:r>
+          </a:p>
+        </p:txBody>
+      </p:sp>
+      <p:sp>
+        <p:nvSpPr>
+          <p:cNvPr id="32" name="TextBox 31">
+            <a:extLst>
+              <a:ext uri="{FF2B5EF4-FFF2-40B4-BE49-F238E27FC236}">
+                <a16:creationId xmlns:a16="http://schemas.microsoft.com/office/drawing/2014/main" id="{B538B151-7B50-6DDC-C802-A5015148EAFB}"/>
+              </a:ext>
+            </a:extLst>
+          </p:cNvPr>
+          <p:cNvSpPr txBox="1"/>
+          <p:nvPr/>
+        </p:nvSpPr>
+        <p:spPr>
+          <a:xfrm>
+            <a:off x="13033826" y="3205342"/>
+            <a:ext cx="2504038" cy="338554"/>
+          </a:xfrm>
+          <a:prstGeom prst="rect">
+            <a:avLst/>
+          </a:prstGeom>
+          <a:noFill/>
+        </p:spPr>
+        <p:txBody>
+          <a:bodyPr wrap="square" rtlCol="0">
+            <a:spAutoFit/>
+          </a:bodyPr>
+          <a:lstStyle/>
+          <a:p>
+            <a:r>
+              <a:rPr lang="en-US" sz="1600" dirty="0"/>
+              <a:t>Public_GitHub (GitHub)</a:t>
+            </a:r>
+          </a:p>
+        </p:txBody>
+      </p:sp>
+      <p:sp>
+        <p:nvSpPr>
+          <p:cNvPr id="33" name="TextBox 32">
+            <a:extLst>
+              <a:ext uri="{FF2B5EF4-FFF2-40B4-BE49-F238E27FC236}">
+                <a16:creationId xmlns:a16="http://schemas.microsoft.com/office/drawing/2014/main" id="{BA31BD76-85E4-2BC2-F0D8-4CEB60B45113}"/>
+              </a:ext>
+            </a:extLst>
+          </p:cNvPr>
+          <p:cNvSpPr txBox="1"/>
+          <p:nvPr/>
+        </p:nvSpPr>
+        <p:spPr>
+          <a:xfrm>
+            <a:off x="13124041" y="6168816"/>
+            <a:ext cx="2098981" cy="261610"/>
+          </a:xfrm>
+          <a:prstGeom prst="rect">
+            <a:avLst/>
+          </a:prstGeom>
+          <a:noFill/>
+        </p:spPr>
+        <p:txBody>
+          <a:bodyPr wrap="square" rtlCol="0">
+            <a:spAutoFit/>
+          </a:bodyPr>
+          <a:lstStyle/>
+          <a:p>
+            <a:r>
+              <a:rPr lang="en-US" sz="1100" dirty="0"/>
+              <a:t>New feature branch (GitLab/…)</a:t>
+            </a:r>
+          </a:p>
+        </p:txBody>
+      </p:sp>
+      <p:sp>
+        <p:nvSpPr>
+          <p:cNvPr id="34" name="TextBox 33">
+            <a:extLst>
+              <a:ext uri="{FF2B5EF4-FFF2-40B4-BE49-F238E27FC236}">
+                <a16:creationId xmlns:a16="http://schemas.microsoft.com/office/drawing/2014/main" id="{04F9C173-B17A-92C1-8E24-1568D0B33229}"/>
+              </a:ext>
+            </a:extLst>
+          </p:cNvPr>
+          <p:cNvSpPr txBox="1"/>
+          <p:nvPr/>
+        </p:nvSpPr>
+        <p:spPr>
+          <a:xfrm>
+            <a:off x="12596554" y="278181"/>
+            <a:ext cx="2674730" cy="338554"/>
+          </a:xfrm>
+          <a:prstGeom prst="rect">
+            <a:avLst/>
+          </a:prstGeom>
+          <a:noFill/>
+        </p:spPr>
+        <p:txBody>
+          <a:bodyPr wrap="square" rtlCol="0">
+            <a:spAutoFit/>
+          </a:bodyPr>
+          <a:lstStyle/>
+          <a:p>
+            <a:r>
+              <a:rPr lang="en-US" sz="1600" dirty="0"/>
+              <a:t>dev branche</a:t>
+            </a:r>
+            <a:r>
+              <a:rPr lang="en-US" sz="1600" dirty="0">
+                <a:solidFill>
+                  <a:srgbClr val="FF0000"/>
+                </a:solidFill>
+                <a:highlight>
+                  <a:srgbClr val="FFFF00"/>
+                </a:highlight>
+              </a:rPr>
+              <a:t>s</a:t>
+            </a:r>
+            <a:r>
+              <a:rPr lang="en-US" sz="1600" dirty="0"/>
+              <a:t> (GitLab/…)</a:t>
+            </a:r>
+          </a:p>
+        </p:txBody>
+      </p:sp>
+      <p:sp>
+        <p:nvSpPr>
+          <p:cNvPr id="5" name="Oval 4">
+            <a:extLst>
+              <a:ext uri="{FF2B5EF4-FFF2-40B4-BE49-F238E27FC236}">
+                <a16:creationId xmlns:a16="http://schemas.microsoft.com/office/drawing/2014/main" id="{44443C8C-66D2-F36E-5C97-C0468421CF1C}"/>
+              </a:ext>
+            </a:extLst>
+          </p:cNvPr>
+          <p:cNvSpPr/>
+          <p:nvPr/>
+        </p:nvSpPr>
+        <p:spPr>
+          <a:xfrm>
+            <a:off x="684889" y="2858707"/>
+            <a:ext cx="432532" cy="432532"/>
+          </a:xfrm>
+          <a:prstGeom prst="ellipse">
+            <a:avLst/>
+          </a:prstGeom>
+        </p:spPr>
+        <p:style>
+          <a:lnRef idx="2">
+            <a:schemeClr val="dk1"/>
+          </a:lnRef>
+          <a:fillRef idx="1">
+            <a:schemeClr val="lt1"/>
+          </a:fillRef>
+          <a:effectRef idx="0">
+            <a:schemeClr val="dk1"/>
+          </a:effectRef>
+          <a:fontRef idx="minor">
+            <a:schemeClr val="dk1"/>
+          </a:fontRef>
+        </p:style>
+        <p:txBody>
+          <a:bodyPr rtlCol="0" anchor="ctr"/>
+          <a:lstStyle/>
+          <a:p>
+            <a:pPr algn="ctr"/>
+            <a:r>
+              <a:rPr lang="en-US" sz="2000" b="1" dirty="0"/>
+              <a:t>O</a:t>
+            </a:r>
+          </a:p>
+        </p:txBody>
+      </p:sp>
+      <p:sp>
+        <p:nvSpPr>
+          <p:cNvPr id="36" name="Oval 35">
+            <a:extLst>
+              <a:ext uri="{FF2B5EF4-FFF2-40B4-BE49-F238E27FC236}">
+                <a16:creationId xmlns:a16="http://schemas.microsoft.com/office/drawing/2014/main" id="{7104FFA0-3EF0-FAF8-0177-C083820A230D}"/>
+              </a:ext>
+            </a:extLst>
+          </p:cNvPr>
+          <p:cNvSpPr/>
+          <p:nvPr/>
+        </p:nvSpPr>
+        <p:spPr>
+          <a:xfrm>
+            <a:off x="2385152" y="656463"/>
+            <a:ext cx="432532" cy="432532"/>
+          </a:xfrm>
+          <a:prstGeom prst="ellipse">
+            <a:avLst/>
+          </a:prstGeom>
+        </p:spPr>
+        <p:style>
+          <a:lnRef idx="2">
+            <a:schemeClr val="dk1"/>
+          </a:lnRef>
+          <a:fillRef idx="1">
+            <a:schemeClr val="lt1"/>
+          </a:fillRef>
+          <a:effectRef idx="0">
+            <a:schemeClr val="dk1"/>
+          </a:effectRef>
+          <a:fontRef idx="minor">
+            <a:schemeClr val="dk1"/>
+          </a:fontRef>
+        </p:style>
+        <p:txBody>
+          <a:bodyPr rtlCol="0" anchor="ctr"/>
+          <a:lstStyle/>
+          <a:p>
+            <a:pPr algn="ctr"/>
+            <a:r>
+              <a:rPr lang="en-US" sz="2000" b="1" dirty="0"/>
+              <a:t>B</a:t>
+            </a:r>
+          </a:p>
+        </p:txBody>
+      </p:sp>
+      <p:sp>
+        <p:nvSpPr>
+          <p:cNvPr id="37" name="Oval 36">
+            <a:extLst>
+              <a:ext uri="{FF2B5EF4-FFF2-40B4-BE49-F238E27FC236}">
+                <a16:creationId xmlns:a16="http://schemas.microsoft.com/office/drawing/2014/main" id="{27923CBC-B0F7-CCB5-97C9-51362FCAE722}"/>
+              </a:ext>
+            </a:extLst>
+          </p:cNvPr>
+          <p:cNvSpPr/>
+          <p:nvPr/>
+        </p:nvSpPr>
+        <p:spPr>
+          <a:xfrm>
+            <a:off x="684889" y="6241073"/>
+            <a:ext cx="432532" cy="432532"/>
+          </a:xfrm>
+          <a:prstGeom prst="ellipse">
+            <a:avLst/>
+          </a:prstGeom>
+        </p:spPr>
+        <p:style>
+          <a:lnRef idx="2">
+            <a:schemeClr val="dk1"/>
+          </a:lnRef>
+          <a:fillRef idx="1">
+            <a:schemeClr val="lt1"/>
+          </a:fillRef>
+          <a:effectRef idx="0">
+            <a:schemeClr val="dk1"/>
+          </a:effectRef>
+          <a:fontRef idx="minor">
+            <a:schemeClr val="dk1"/>
+          </a:fontRef>
+        </p:style>
+        <p:txBody>
+          <a:bodyPr rtlCol="0" anchor="ctr"/>
+          <a:lstStyle/>
+          <a:p>
+            <a:pPr algn="ctr"/>
+            <a:r>
+              <a:rPr lang="en-US" sz="2000" b="1" dirty="0"/>
+              <a:t>O</a:t>
+            </a:r>
+          </a:p>
+        </p:txBody>
+      </p:sp>
+      <p:cxnSp>
+        <p:nvCxnSpPr>
+          <p:cNvPr id="40" name="Straight Arrow Connector 39">
+            <a:extLst>
+              <a:ext uri="{FF2B5EF4-FFF2-40B4-BE49-F238E27FC236}">
+                <a16:creationId xmlns:a16="http://schemas.microsoft.com/office/drawing/2014/main" id="{32270EDD-67B3-9A08-C717-603EECE04590}"/>
+              </a:ext>
+            </a:extLst>
+          </p:cNvPr>
+          <p:cNvCxnSpPr>
+            <a:cxnSpLocks/>
+            <a:stCxn id="5" idx="4"/>
+            <a:endCxn id="37" idx="0"/>
+          </p:cNvCxnSpPr>
+          <p:nvPr/>
+        </p:nvCxnSpPr>
+        <p:spPr>
+          <a:xfrm>
+            <a:off x="901155" y="3291239"/>
+            <a:ext cx="0" cy="2949834"/>
+          </a:xfrm>
+          <a:prstGeom prst="straightConnector1">
+            <a:avLst/>
+          </a:prstGeom>
+          <a:ln>
+            <a:headEnd type="none" w="med" len="med"/>
+            <a:tailEnd type="arrow" w="med" len="med"/>
+          </a:ln>
+        </p:spPr>
+        <p:style>
+          <a:lnRef idx="3">
+            <a:schemeClr val="accent1"/>
+          </a:lnRef>
+          <a:fillRef idx="0">
+            <a:schemeClr val="accent1"/>
+          </a:fillRef>
+          <a:effectRef idx="2">
+            <a:schemeClr val="accent1"/>
+          </a:effectRef>
+          <a:fontRef idx="minor">
+            <a:schemeClr val="tx1"/>
+          </a:fontRef>
+        </p:style>
+      </p:cxnSp>
+      <p:sp>
+        <p:nvSpPr>
+          <p:cNvPr id="44" name="TextBox 43">
+            <a:extLst>
+              <a:ext uri="{FF2B5EF4-FFF2-40B4-BE49-F238E27FC236}">
+                <a16:creationId xmlns:a16="http://schemas.microsoft.com/office/drawing/2014/main" id="{C0182233-A922-E6F6-9CE1-8685751BF7DA}"/>
+              </a:ext>
+            </a:extLst>
+          </p:cNvPr>
+          <p:cNvSpPr txBox="1"/>
+          <p:nvPr/>
+        </p:nvSpPr>
+        <p:spPr>
+          <a:xfrm rot="16200000">
+            <a:off x="391881" y="1937627"/>
+            <a:ext cx="430887" cy="587661"/>
+          </a:xfrm>
+          <a:prstGeom prst="rect">
+            <a:avLst/>
+          </a:prstGeom>
+          <a:noFill/>
+        </p:spPr>
+        <p:txBody>
+          <a:bodyPr vert="eaVert" wrap="none" rtlCol="0">
+            <a:spAutoFit/>
+          </a:bodyPr>
+          <a:lstStyle/>
+          <a:p>
+            <a:r>
+              <a:rPr lang="en-US" sz="1600" dirty="0"/>
+              <a:t>clone</a:t>
+            </a:r>
+          </a:p>
+        </p:txBody>
+      </p:sp>
+      <p:sp>
+        <p:nvSpPr>
+          <p:cNvPr id="45" name="TextBox 44">
+            <a:extLst>
+              <a:ext uri="{FF2B5EF4-FFF2-40B4-BE49-F238E27FC236}">
+                <a16:creationId xmlns:a16="http://schemas.microsoft.com/office/drawing/2014/main" id="{4A53CE37-D747-17FD-04B2-070B5FBAC3FC}"/>
+              </a:ext>
+            </a:extLst>
+          </p:cNvPr>
+          <p:cNvSpPr txBox="1"/>
+          <p:nvPr/>
+        </p:nvSpPr>
+        <p:spPr>
+          <a:xfrm rot="16200000">
+            <a:off x="391881" y="4757023"/>
+            <a:ext cx="430887" cy="587661"/>
+          </a:xfrm>
+          <a:prstGeom prst="rect">
+            <a:avLst/>
+          </a:prstGeom>
+          <a:noFill/>
+        </p:spPr>
+        <p:txBody>
+          <a:bodyPr vert="eaVert" wrap="none" rtlCol="0">
+            <a:spAutoFit/>
+          </a:bodyPr>
+          <a:lstStyle/>
+          <a:p>
+            <a:r>
+              <a:rPr lang="en-US" sz="1600" dirty="0"/>
+              <a:t>clone</a:t>
+            </a:r>
+          </a:p>
+        </p:txBody>
+      </p:sp>
+      <p:sp>
+        <p:nvSpPr>
+          <p:cNvPr id="48" name="Oval 47">
+            <a:extLst>
+              <a:ext uri="{FF2B5EF4-FFF2-40B4-BE49-F238E27FC236}">
+                <a16:creationId xmlns:a16="http://schemas.microsoft.com/office/drawing/2014/main" id="{6B975FF8-436F-603E-5F4B-34C95487E620}"/>
+              </a:ext>
+            </a:extLst>
+          </p:cNvPr>
+          <p:cNvSpPr/>
+          <p:nvPr/>
+        </p:nvSpPr>
+        <p:spPr>
+          <a:xfrm>
+            <a:off x="1589549" y="650377"/>
+            <a:ext cx="432532" cy="432532"/>
+          </a:xfrm>
+          <a:prstGeom prst="ellipse">
+            <a:avLst/>
+          </a:prstGeom>
+        </p:spPr>
+        <p:style>
+          <a:lnRef idx="2">
+            <a:schemeClr val="dk1"/>
+          </a:lnRef>
+          <a:fillRef idx="1">
+            <a:schemeClr val="lt1"/>
+          </a:fillRef>
+          <a:effectRef idx="0">
+            <a:schemeClr val="dk1"/>
+          </a:effectRef>
+          <a:fontRef idx="minor">
+            <a:schemeClr val="dk1"/>
+          </a:fontRef>
+        </p:style>
+        <p:txBody>
+          <a:bodyPr rtlCol="0" anchor="ctr"/>
+          <a:lstStyle/>
+          <a:p>
+            <a:pPr algn="ctr"/>
+            <a:r>
+              <a:rPr lang="en-US" sz="2000" b="1" dirty="0"/>
+              <a:t>A</a:t>
+            </a:r>
+          </a:p>
+        </p:txBody>
+      </p:sp>
+      <p:sp>
+        <p:nvSpPr>
+          <p:cNvPr id="49" name="Oval 48">
+            <a:extLst>
+              <a:ext uri="{FF2B5EF4-FFF2-40B4-BE49-F238E27FC236}">
+                <a16:creationId xmlns:a16="http://schemas.microsoft.com/office/drawing/2014/main" id="{D70ADB25-3A82-5D41-973B-FF557EA50C49}"/>
+              </a:ext>
+            </a:extLst>
+          </p:cNvPr>
+          <p:cNvSpPr/>
+          <p:nvPr/>
+        </p:nvSpPr>
+        <p:spPr>
+          <a:xfrm>
+            <a:off x="3221738" y="667752"/>
+            <a:ext cx="432532" cy="432532"/>
+          </a:xfrm>
+          <a:prstGeom prst="ellipse">
+            <a:avLst/>
+          </a:prstGeom>
+        </p:spPr>
+        <p:style>
+          <a:lnRef idx="2">
+            <a:schemeClr val="dk1"/>
+          </a:lnRef>
+          <a:fillRef idx="1">
+            <a:schemeClr val="lt1"/>
+          </a:fillRef>
+          <a:effectRef idx="0">
+            <a:schemeClr val="dk1"/>
+          </a:effectRef>
+          <a:fontRef idx="minor">
+            <a:schemeClr val="dk1"/>
+          </a:fontRef>
+        </p:style>
+        <p:txBody>
+          <a:bodyPr rtlCol="0" anchor="ctr"/>
+          <a:lstStyle/>
+          <a:p>
+            <a:pPr algn="ctr"/>
+            <a:r>
+              <a:rPr lang="en-US" sz="2000" b="1" dirty="0"/>
+              <a:t>C</a:t>
+            </a:r>
+          </a:p>
+        </p:txBody>
+      </p:sp>
+      <p:sp>
+        <p:nvSpPr>
+          <p:cNvPr id="50" name="Oval 49">
+            <a:extLst>
+              <a:ext uri="{FF2B5EF4-FFF2-40B4-BE49-F238E27FC236}">
+                <a16:creationId xmlns:a16="http://schemas.microsoft.com/office/drawing/2014/main" id="{2D121296-E926-9B91-CCCE-A7220FE1E7A2}"/>
+              </a:ext>
+            </a:extLst>
+          </p:cNvPr>
+          <p:cNvSpPr/>
+          <p:nvPr/>
+        </p:nvSpPr>
+        <p:spPr>
+          <a:xfrm>
+            <a:off x="683098" y="656463"/>
+            <a:ext cx="432532" cy="432532"/>
+          </a:xfrm>
+          <a:prstGeom prst="ellipse">
+            <a:avLst/>
+          </a:prstGeom>
+        </p:spPr>
+        <p:style>
+          <a:lnRef idx="2">
+            <a:schemeClr val="dk1"/>
+          </a:lnRef>
+          <a:fillRef idx="1">
+            <a:schemeClr val="lt1"/>
+          </a:fillRef>
+          <a:effectRef idx="0">
+            <a:schemeClr val="dk1"/>
+          </a:effectRef>
+          <a:fontRef idx="minor">
+            <a:schemeClr val="dk1"/>
+          </a:fontRef>
+        </p:style>
+        <p:txBody>
+          <a:bodyPr rtlCol="0" anchor="ctr"/>
+          <a:lstStyle/>
+          <a:p>
+            <a:pPr algn="ctr"/>
+            <a:r>
+              <a:rPr lang="en-US" sz="2000" b="1" dirty="0"/>
+              <a:t>O</a:t>
+            </a:r>
+          </a:p>
+        </p:txBody>
+      </p:sp>
+      <p:sp>
+        <p:nvSpPr>
+          <p:cNvPr id="57" name="TextBox 56">
+            <a:extLst>
+              <a:ext uri="{FF2B5EF4-FFF2-40B4-BE49-F238E27FC236}">
+                <a16:creationId xmlns:a16="http://schemas.microsoft.com/office/drawing/2014/main" id="{71A18010-69D1-0A7F-E0E6-B9C69D8B975B}"/>
+              </a:ext>
+            </a:extLst>
+          </p:cNvPr>
+          <p:cNvSpPr txBox="1"/>
+          <p:nvPr/>
+        </p:nvSpPr>
+        <p:spPr>
+          <a:xfrm>
+            <a:off x="13460669" y="1786664"/>
+            <a:ext cx="2000615" cy="338554"/>
+          </a:xfrm>
+          <a:prstGeom prst="rect">
+            <a:avLst/>
+          </a:prstGeom>
+          <a:noFill/>
+        </p:spPr>
+        <p:txBody>
+          <a:bodyPr wrap="square" rtlCol="0">
+            <a:spAutoFit/>
+          </a:bodyPr>
+          <a:lstStyle/>
+          <a:p>
+            <a:r>
+              <a:rPr lang="en-US" sz="1600" dirty="0"/>
+              <a:t>ForGitHub (GitLab)</a:t>
+            </a:r>
+          </a:p>
+        </p:txBody>
+      </p:sp>
+      <p:cxnSp>
+        <p:nvCxnSpPr>
+          <p:cNvPr id="59" name="Straight Arrow Connector 58">
+            <a:extLst>
+              <a:ext uri="{FF2B5EF4-FFF2-40B4-BE49-F238E27FC236}">
+                <a16:creationId xmlns:a16="http://schemas.microsoft.com/office/drawing/2014/main" id="{BEB35588-1B35-BD1C-3127-73E25C10F6B3}"/>
+              </a:ext>
+            </a:extLst>
+          </p:cNvPr>
+          <p:cNvCxnSpPr>
+            <a:cxnSpLocks/>
+            <a:stCxn id="50" idx="5"/>
+            <a:endCxn id="6" idx="2"/>
+          </p:cNvCxnSpPr>
+          <p:nvPr/>
+        </p:nvCxnSpPr>
+        <p:spPr>
+          <a:xfrm>
+            <a:off x="1052287" y="1025652"/>
+            <a:ext cx="2573463" cy="955711"/>
+          </a:xfrm>
+          <a:prstGeom prst="straightConnector1">
+            <a:avLst/>
+          </a:prstGeom>
+          <a:ln>
+            <a:headEnd type="none" w="med" len="med"/>
+            <a:tailEnd type="arrow" w="med" len="med"/>
+          </a:ln>
+        </p:spPr>
+        <p:style>
+          <a:lnRef idx="3">
+            <a:schemeClr val="accent1"/>
+          </a:lnRef>
+          <a:fillRef idx="0">
+            <a:schemeClr val="accent1"/>
+          </a:fillRef>
+          <a:effectRef idx="2">
+            <a:schemeClr val="accent1"/>
+          </a:effectRef>
+          <a:fontRef idx="minor">
+            <a:schemeClr val="tx1"/>
+          </a:fontRef>
+        </p:style>
+      </p:cxnSp>
+      <p:sp>
+        <p:nvSpPr>
+          <p:cNvPr id="60" name="TextBox 59">
+            <a:extLst>
+              <a:ext uri="{FF2B5EF4-FFF2-40B4-BE49-F238E27FC236}">
+                <a16:creationId xmlns:a16="http://schemas.microsoft.com/office/drawing/2014/main" id="{3FE426C8-7DBF-B688-3611-BBD793B3D3F1}"/>
+              </a:ext>
+            </a:extLst>
+          </p:cNvPr>
+          <p:cNvSpPr txBox="1"/>
+          <p:nvPr/>
+        </p:nvSpPr>
+        <p:spPr>
+          <a:xfrm>
+            <a:off x="3654270" y="1818923"/>
+            <a:ext cx="481869" cy="338554"/>
+          </a:xfrm>
+          <a:prstGeom prst="rect">
+            <a:avLst/>
+          </a:prstGeom>
+          <a:noFill/>
+        </p:spPr>
+        <p:txBody>
+          <a:bodyPr wrap="square" rtlCol="0">
+            <a:spAutoFit/>
+          </a:bodyPr>
+          <a:lstStyle/>
+          <a:p>
+            <a:r>
+              <a:rPr lang="en-US" sz="1600" b="1" dirty="0"/>
+              <a:t>S1</a:t>
+            </a:r>
+          </a:p>
+        </p:txBody>
+      </p:sp>
+      <p:cxnSp>
+        <p:nvCxnSpPr>
+          <p:cNvPr id="64" name="Straight Arrow Connector 63">
+            <a:extLst>
+              <a:ext uri="{FF2B5EF4-FFF2-40B4-BE49-F238E27FC236}">
+                <a16:creationId xmlns:a16="http://schemas.microsoft.com/office/drawing/2014/main" id="{B78031E4-4E5D-A7B8-A852-72D41F21890A}"/>
+              </a:ext>
+            </a:extLst>
+          </p:cNvPr>
+          <p:cNvCxnSpPr>
+            <a:cxnSpLocks/>
+            <a:stCxn id="49" idx="4"/>
+            <a:endCxn id="6" idx="0"/>
+          </p:cNvCxnSpPr>
+          <p:nvPr/>
+        </p:nvCxnSpPr>
+        <p:spPr>
+          <a:xfrm>
+            <a:off x="3438004" y="1100284"/>
+            <a:ext cx="404012" cy="664813"/>
+          </a:xfrm>
+          <a:prstGeom prst="straightConnector1">
+            <a:avLst/>
+          </a:prstGeom>
+          <a:ln w="28575" cap="flat" cmpd="sng" algn="ctr">
+            <a:solidFill>
+              <a:schemeClr val="accent2"/>
+            </a:solidFill>
+            <a:prstDash val="sysDot"/>
+            <a:round/>
+            <a:headEnd type="none" w="med" len="med"/>
+            <a:tailEnd type="arrow" w="med" len="med"/>
+          </a:ln>
+        </p:spPr>
+        <p:style>
+          <a:lnRef idx="0">
+            <a:scrgbClr r="0" g="0" b="0"/>
+          </a:lnRef>
+          <a:fillRef idx="0">
+            <a:scrgbClr r="0" g="0" b="0"/>
+          </a:fillRef>
+          <a:effectRef idx="0">
+            <a:scrgbClr r="0" g="0" b="0"/>
+          </a:effectRef>
+          <a:fontRef idx="minor">
+            <a:schemeClr val="tx1"/>
+          </a:fontRef>
+        </p:style>
+      </p:cxnSp>
+      <p:sp>
+        <p:nvSpPr>
+          <p:cNvPr id="66" name="TextBox 65">
+            <a:extLst>
+              <a:ext uri="{FF2B5EF4-FFF2-40B4-BE49-F238E27FC236}">
+                <a16:creationId xmlns:a16="http://schemas.microsoft.com/office/drawing/2014/main" id="{86A79676-9779-CFC2-889A-D080D320B906}"/>
+              </a:ext>
+            </a:extLst>
+          </p:cNvPr>
+          <p:cNvSpPr txBox="1"/>
+          <p:nvPr/>
+        </p:nvSpPr>
+        <p:spPr>
+          <a:xfrm rot="16200000">
+            <a:off x="5304228" y="-371304"/>
+            <a:ext cx="738664" cy="3663088"/>
+          </a:xfrm>
+          <a:prstGeom prst="rect">
+            <a:avLst/>
+          </a:prstGeom>
+          <a:noFill/>
+        </p:spPr>
+        <p:txBody>
+          <a:bodyPr vert="eaVert" wrap="square" rtlCol="0">
+            <a:spAutoFit/>
+          </a:bodyPr>
+          <a:lstStyle/>
+          <a:p>
+            <a:r>
+              <a:rPr lang="en-US" sz="1200" dirty="0">
+                <a:solidFill>
+                  <a:schemeClr val="accent2"/>
+                </a:solidFill>
+              </a:rPr>
+              <a:t>git merge –squash</a:t>
+            </a:r>
+            <a:br>
+              <a:rPr lang="en-US" sz="1200" dirty="0">
+                <a:solidFill>
+                  <a:schemeClr val="accent2"/>
+                </a:solidFill>
+              </a:rPr>
+            </a:br>
+            <a:r>
+              <a:rPr lang="en-US" sz="1200" dirty="0">
+                <a:solidFill>
+                  <a:schemeClr val="accent2"/>
+                </a:solidFill>
+              </a:rPr>
+              <a:t>squash changes from A to C</a:t>
+            </a:r>
+            <a:br>
+              <a:rPr lang="en-US" sz="1200" dirty="0">
+                <a:solidFill>
+                  <a:schemeClr val="accent2"/>
+                </a:solidFill>
+              </a:rPr>
+            </a:br>
+            <a:r>
+              <a:rPr lang="en-US" sz="1200" dirty="0">
+                <a:solidFill>
+                  <a:schemeClr val="accent2"/>
+                </a:solidFill>
+              </a:rPr>
+              <a:t>Create S1, whose only parent is O</a:t>
+            </a:r>
+          </a:p>
+        </p:txBody>
+      </p:sp>
+      <p:cxnSp>
+        <p:nvCxnSpPr>
+          <p:cNvPr id="67" name="Straight Arrow Connector 66">
+            <a:extLst>
+              <a:ext uri="{FF2B5EF4-FFF2-40B4-BE49-F238E27FC236}">
+                <a16:creationId xmlns:a16="http://schemas.microsoft.com/office/drawing/2014/main" id="{A93DD46C-6F83-52D8-37DF-FCEDC036FBFA}"/>
+              </a:ext>
+            </a:extLst>
+          </p:cNvPr>
+          <p:cNvCxnSpPr>
+            <a:cxnSpLocks/>
+            <a:stCxn id="6" idx="4"/>
+            <a:endCxn id="84" idx="0"/>
+          </p:cNvCxnSpPr>
+          <p:nvPr/>
+        </p:nvCxnSpPr>
+        <p:spPr>
+          <a:xfrm>
+            <a:off x="3842016" y="2197629"/>
+            <a:ext cx="8390" cy="657924"/>
+          </a:xfrm>
+          <a:prstGeom prst="straightConnector1">
+            <a:avLst/>
+          </a:prstGeom>
+          <a:ln>
+            <a:headEnd type="none" w="med" len="med"/>
+            <a:tailEnd type="arrow" w="med" len="med"/>
+          </a:ln>
+        </p:spPr>
+        <p:style>
+          <a:lnRef idx="3">
+            <a:schemeClr val="accent1"/>
+          </a:lnRef>
+          <a:fillRef idx="0">
+            <a:schemeClr val="accent1"/>
+          </a:fillRef>
+          <a:effectRef idx="2">
+            <a:schemeClr val="accent1"/>
+          </a:effectRef>
+          <a:fontRef idx="minor">
+            <a:schemeClr val="tx1"/>
+          </a:fontRef>
+        </p:style>
+      </p:cxnSp>
+      <p:sp>
+        <p:nvSpPr>
+          <p:cNvPr id="71" name="TextBox 70">
+            <a:extLst>
+              <a:ext uri="{FF2B5EF4-FFF2-40B4-BE49-F238E27FC236}">
+                <a16:creationId xmlns:a16="http://schemas.microsoft.com/office/drawing/2014/main" id="{A5CD4A03-D12B-F830-FD29-97E8C5511824}"/>
+              </a:ext>
+            </a:extLst>
+          </p:cNvPr>
+          <p:cNvSpPr txBox="1"/>
+          <p:nvPr/>
+        </p:nvSpPr>
+        <p:spPr>
+          <a:xfrm rot="16200000">
+            <a:off x="5023231" y="973266"/>
+            <a:ext cx="861774" cy="3147107"/>
+          </a:xfrm>
+          <a:prstGeom prst="rect">
+            <a:avLst/>
+          </a:prstGeom>
+          <a:noFill/>
+        </p:spPr>
+        <p:txBody>
+          <a:bodyPr vert="eaVert" wrap="square" rtlCol="0">
+            <a:spAutoFit/>
+          </a:bodyPr>
+          <a:lstStyle/>
+          <a:p>
+            <a:r>
+              <a:rPr lang="en-US" sz="1100" dirty="0"/>
+              <a:t>Pull Request. If accept with merge (no squash) and the PR platform (i.e. GitHub) allows fast forward, this will result in Public_GitHub fast forwarded to S1. If not, a new merge commit S1’ will be created</a:t>
+            </a:r>
+          </a:p>
+        </p:txBody>
+      </p:sp>
+      <p:sp>
+        <p:nvSpPr>
+          <p:cNvPr id="72" name="TextBox 71">
+            <a:extLst>
+              <a:ext uri="{FF2B5EF4-FFF2-40B4-BE49-F238E27FC236}">
+                <a16:creationId xmlns:a16="http://schemas.microsoft.com/office/drawing/2014/main" id="{FCF1E21C-158C-8C3F-129E-4CF5173A03FB}"/>
+              </a:ext>
+            </a:extLst>
+          </p:cNvPr>
+          <p:cNvSpPr txBox="1"/>
+          <p:nvPr/>
+        </p:nvSpPr>
+        <p:spPr>
+          <a:xfrm>
+            <a:off x="1256053" y="238336"/>
+            <a:ext cx="2425037" cy="461665"/>
+          </a:xfrm>
+          <a:prstGeom prst="rect">
+            <a:avLst/>
+          </a:prstGeom>
+          <a:noFill/>
+        </p:spPr>
+        <p:txBody>
+          <a:bodyPr wrap="square" rtlCol="0">
+            <a:spAutoFit/>
+          </a:bodyPr>
+          <a:lstStyle/>
+          <a:p>
+            <a:r>
+              <a:rPr lang="en-US" sz="1200" dirty="0">
+                <a:solidFill>
+                  <a:srgbClr val="FF0000"/>
+                </a:solidFill>
+              </a:rPr>
+              <a:t>dev commits A and B can be messy with PHI and secret</a:t>
+            </a:r>
+          </a:p>
+        </p:txBody>
+      </p:sp>
+      <p:sp>
+        <p:nvSpPr>
+          <p:cNvPr id="73" name="TextBox 72">
+            <a:extLst>
+              <a:ext uri="{FF2B5EF4-FFF2-40B4-BE49-F238E27FC236}">
+                <a16:creationId xmlns:a16="http://schemas.microsoft.com/office/drawing/2014/main" id="{FAC5CB92-B73F-D00A-0E41-1C14762B65DD}"/>
+              </a:ext>
+            </a:extLst>
+          </p:cNvPr>
+          <p:cNvSpPr txBox="1"/>
+          <p:nvPr/>
+        </p:nvSpPr>
+        <p:spPr>
+          <a:xfrm>
+            <a:off x="3540825" y="209695"/>
+            <a:ext cx="2000615" cy="461665"/>
+          </a:xfrm>
+          <a:prstGeom prst="rect">
+            <a:avLst/>
+          </a:prstGeom>
+          <a:noFill/>
+        </p:spPr>
+        <p:txBody>
+          <a:bodyPr wrap="square" rtlCol="0">
+            <a:spAutoFit/>
+          </a:bodyPr>
+          <a:lstStyle/>
+          <a:p>
+            <a:r>
+              <a:rPr lang="en-US" sz="1200" dirty="0">
+                <a:solidFill>
+                  <a:srgbClr val="00B050"/>
+                </a:solidFill>
+              </a:rPr>
+              <a:t>C clean up mess in A and B</a:t>
+            </a:r>
+            <a:br>
+              <a:rPr lang="en-US" sz="1200" dirty="0">
+                <a:solidFill>
+                  <a:srgbClr val="00B050"/>
+                </a:solidFill>
+              </a:rPr>
+            </a:br>
+            <a:r>
+              <a:rPr lang="en-US" sz="1200" dirty="0">
+                <a:solidFill>
+                  <a:srgbClr val="00B050"/>
+                </a:solidFill>
+              </a:rPr>
+              <a:t>and ready to publish</a:t>
+            </a:r>
+          </a:p>
+        </p:txBody>
+      </p:sp>
+      <p:sp>
+        <p:nvSpPr>
+          <p:cNvPr id="84" name="Oval 83">
+            <a:extLst>
+              <a:ext uri="{FF2B5EF4-FFF2-40B4-BE49-F238E27FC236}">
+                <a16:creationId xmlns:a16="http://schemas.microsoft.com/office/drawing/2014/main" id="{A5B693BB-D505-E2D5-3046-70EF8E024052}"/>
+              </a:ext>
+            </a:extLst>
+          </p:cNvPr>
+          <p:cNvSpPr/>
+          <p:nvPr/>
+        </p:nvSpPr>
+        <p:spPr>
+          <a:xfrm>
+            <a:off x="3634140" y="2855553"/>
+            <a:ext cx="432532" cy="432532"/>
+          </a:xfrm>
+          <a:prstGeom prst="ellipse">
+            <a:avLst/>
+          </a:prstGeom>
+        </p:spPr>
+        <p:style>
+          <a:lnRef idx="2">
+            <a:schemeClr val="dk1"/>
+          </a:lnRef>
+          <a:fillRef idx="1">
+            <a:schemeClr val="lt1"/>
+          </a:fillRef>
+          <a:effectRef idx="0">
+            <a:schemeClr val="dk1"/>
+          </a:effectRef>
+          <a:fontRef idx="minor">
+            <a:schemeClr val="dk1"/>
+          </a:fontRef>
+        </p:style>
+        <p:txBody>
+          <a:bodyPr rtlCol="0" anchor="ctr"/>
+          <a:lstStyle/>
+          <a:p>
+            <a:pPr algn="ctr"/>
+            <a:endParaRPr lang="en-US" sz="800" b="1" dirty="0"/>
+          </a:p>
+        </p:txBody>
+      </p:sp>
+      <p:sp>
+        <p:nvSpPr>
+          <p:cNvPr id="85" name="TextBox 84">
+            <a:extLst>
+              <a:ext uri="{FF2B5EF4-FFF2-40B4-BE49-F238E27FC236}">
+                <a16:creationId xmlns:a16="http://schemas.microsoft.com/office/drawing/2014/main" id="{F69D124E-D92B-DBD1-2D72-60A6F453EC87}"/>
+              </a:ext>
+            </a:extLst>
+          </p:cNvPr>
+          <p:cNvSpPr txBox="1"/>
+          <p:nvPr/>
+        </p:nvSpPr>
+        <p:spPr>
+          <a:xfrm>
+            <a:off x="3662660" y="2909379"/>
+            <a:ext cx="481869" cy="338554"/>
+          </a:xfrm>
+          <a:prstGeom prst="rect">
+            <a:avLst/>
+          </a:prstGeom>
+          <a:noFill/>
+        </p:spPr>
+        <p:txBody>
+          <a:bodyPr wrap="square" rtlCol="0">
+            <a:spAutoFit/>
+          </a:bodyPr>
+          <a:lstStyle/>
+          <a:p>
+            <a:r>
+              <a:rPr lang="en-US" sz="1600" b="1" dirty="0"/>
+              <a:t>S1</a:t>
+            </a:r>
+          </a:p>
+        </p:txBody>
+      </p:sp>
+      <p:sp>
+        <p:nvSpPr>
+          <p:cNvPr id="86" name="Oval 85">
+            <a:extLst>
+              <a:ext uri="{FF2B5EF4-FFF2-40B4-BE49-F238E27FC236}">
+                <a16:creationId xmlns:a16="http://schemas.microsoft.com/office/drawing/2014/main" id="{E369237F-4909-2637-E56A-B005B9AF1601}"/>
+              </a:ext>
+            </a:extLst>
+          </p:cNvPr>
+          <p:cNvSpPr/>
+          <p:nvPr/>
+        </p:nvSpPr>
+        <p:spPr>
+          <a:xfrm>
+            <a:off x="3593394" y="6232590"/>
+            <a:ext cx="432532" cy="432532"/>
+          </a:xfrm>
+          <a:prstGeom prst="ellipse">
+            <a:avLst/>
+          </a:prstGeom>
+        </p:spPr>
+        <p:style>
+          <a:lnRef idx="2">
+            <a:schemeClr val="dk1"/>
+          </a:lnRef>
+          <a:fillRef idx="1">
+            <a:schemeClr val="lt1"/>
+          </a:fillRef>
+          <a:effectRef idx="0">
+            <a:schemeClr val="dk1"/>
+          </a:effectRef>
+          <a:fontRef idx="minor">
+            <a:schemeClr val="dk1"/>
+          </a:fontRef>
+        </p:style>
+        <p:txBody>
+          <a:bodyPr rtlCol="0" anchor="ctr"/>
+          <a:lstStyle/>
+          <a:p>
+            <a:pPr algn="ctr"/>
+            <a:r>
+              <a:rPr lang="en-US" sz="2000" b="1" dirty="0"/>
+              <a:t>E</a:t>
+            </a:r>
+          </a:p>
+        </p:txBody>
+      </p:sp>
+      <p:sp>
+        <p:nvSpPr>
+          <p:cNvPr id="87" name="Oval 86">
+            <a:extLst>
+              <a:ext uri="{FF2B5EF4-FFF2-40B4-BE49-F238E27FC236}">
+                <a16:creationId xmlns:a16="http://schemas.microsoft.com/office/drawing/2014/main" id="{C8967022-770B-8FA7-C61A-BFBBBF257AC8}"/>
+              </a:ext>
+            </a:extLst>
+          </p:cNvPr>
+          <p:cNvSpPr/>
+          <p:nvPr/>
+        </p:nvSpPr>
+        <p:spPr>
+          <a:xfrm>
+            <a:off x="5155090" y="6241073"/>
+            <a:ext cx="432532" cy="432532"/>
+          </a:xfrm>
+          <a:prstGeom prst="ellipse">
+            <a:avLst/>
+          </a:prstGeom>
+        </p:spPr>
+        <p:style>
+          <a:lnRef idx="2">
+            <a:schemeClr val="dk1"/>
+          </a:lnRef>
+          <a:fillRef idx="1">
+            <a:schemeClr val="lt1"/>
+          </a:fillRef>
+          <a:effectRef idx="0">
+            <a:schemeClr val="dk1"/>
+          </a:effectRef>
+          <a:fontRef idx="minor">
+            <a:schemeClr val="dk1"/>
+          </a:fontRef>
+        </p:style>
+        <p:txBody>
+          <a:bodyPr rtlCol="0" anchor="ctr"/>
+          <a:lstStyle/>
+          <a:p>
+            <a:pPr algn="ctr"/>
+            <a:r>
+              <a:rPr lang="en-US" sz="2000" b="1" dirty="0"/>
+              <a:t>F</a:t>
+            </a:r>
+          </a:p>
+        </p:txBody>
+      </p:sp>
+      <p:sp>
+        <p:nvSpPr>
+          <p:cNvPr id="96" name="TextBox 95">
+            <a:extLst>
+              <a:ext uri="{FF2B5EF4-FFF2-40B4-BE49-F238E27FC236}">
+                <a16:creationId xmlns:a16="http://schemas.microsoft.com/office/drawing/2014/main" id="{F072EDCB-1CFD-391D-2EF2-F4E3DC61C2C2}"/>
+              </a:ext>
+            </a:extLst>
+          </p:cNvPr>
+          <p:cNvSpPr txBox="1"/>
+          <p:nvPr/>
+        </p:nvSpPr>
+        <p:spPr>
+          <a:xfrm>
+            <a:off x="1799850" y="6636891"/>
+            <a:ext cx="4392893" cy="276999"/>
+          </a:xfrm>
+          <a:prstGeom prst="rect">
+            <a:avLst/>
+          </a:prstGeom>
+          <a:noFill/>
+        </p:spPr>
+        <p:txBody>
+          <a:bodyPr wrap="square" rtlCol="0">
+            <a:spAutoFit/>
+          </a:bodyPr>
+          <a:lstStyle/>
+          <a:p>
+            <a:r>
+              <a:rPr lang="en-US" sz="1200" dirty="0">
+                <a:solidFill>
+                  <a:srgbClr val="FF0000"/>
+                </a:solidFill>
+              </a:rPr>
+              <a:t>dev commits D, E, and F can be messy with PHI and secret</a:t>
+            </a:r>
+          </a:p>
+        </p:txBody>
+      </p:sp>
+      <p:sp>
+        <p:nvSpPr>
+          <p:cNvPr id="106" name="Oval 105">
+            <a:extLst>
+              <a:ext uri="{FF2B5EF4-FFF2-40B4-BE49-F238E27FC236}">
+                <a16:creationId xmlns:a16="http://schemas.microsoft.com/office/drawing/2014/main" id="{8B5A0811-036F-5AD8-C620-623C47575217}"/>
+              </a:ext>
+            </a:extLst>
+          </p:cNvPr>
+          <p:cNvSpPr/>
+          <p:nvPr/>
+        </p:nvSpPr>
+        <p:spPr>
+          <a:xfrm>
+            <a:off x="12433274" y="6232590"/>
+            <a:ext cx="432532" cy="432532"/>
+          </a:xfrm>
+          <a:prstGeom prst="ellipse">
+            <a:avLst/>
+          </a:prstGeom>
+        </p:spPr>
+        <p:style>
+          <a:lnRef idx="2">
+            <a:schemeClr val="dk1"/>
+          </a:lnRef>
+          <a:fillRef idx="1">
+            <a:schemeClr val="lt1"/>
+          </a:fillRef>
+          <a:effectRef idx="0">
+            <a:schemeClr val="dk1"/>
+          </a:effectRef>
+          <a:fontRef idx="minor">
+            <a:schemeClr val="dk1"/>
+          </a:fontRef>
+        </p:style>
+        <p:txBody>
+          <a:bodyPr rtlCol="0" anchor="ctr"/>
+          <a:lstStyle/>
+          <a:p>
+            <a:pPr algn="ctr"/>
+            <a:r>
+              <a:rPr lang="en-US" sz="2000" b="1" dirty="0"/>
+              <a:t>H</a:t>
+            </a:r>
+          </a:p>
+        </p:txBody>
+      </p:sp>
+      <p:sp>
+        <p:nvSpPr>
+          <p:cNvPr id="125" name="TextBox 124">
+            <a:extLst>
+              <a:ext uri="{FF2B5EF4-FFF2-40B4-BE49-F238E27FC236}">
+                <a16:creationId xmlns:a16="http://schemas.microsoft.com/office/drawing/2014/main" id="{AD43A922-D339-0C36-6191-4CE9076780E8}"/>
+              </a:ext>
+            </a:extLst>
+          </p:cNvPr>
+          <p:cNvSpPr txBox="1"/>
+          <p:nvPr/>
+        </p:nvSpPr>
+        <p:spPr>
+          <a:xfrm rot="11219425">
+            <a:off x="7606225" y="3293217"/>
+            <a:ext cx="507831" cy="2723595"/>
+          </a:xfrm>
+          <a:prstGeom prst="rect">
+            <a:avLst/>
+          </a:prstGeom>
+          <a:noFill/>
+        </p:spPr>
+        <p:txBody>
+          <a:bodyPr vert="eaVert" wrap="square" rtlCol="0">
+            <a:spAutoFit/>
+          </a:bodyPr>
+          <a:lstStyle/>
+          <a:p>
+            <a:r>
+              <a:rPr lang="en-US" sz="1050" b="1" dirty="0">
+                <a:solidFill>
+                  <a:schemeClr val="accent2"/>
+                </a:solidFill>
+              </a:rPr>
+              <a:t>Merge from private dev to Public </a:t>
+            </a:r>
+            <a:r>
+              <a:rPr lang="en-US" sz="1050" b="1" dirty="0">
+                <a:solidFill>
+                  <a:schemeClr val="accent2"/>
+                </a:solidFill>
+                <a:highlight>
+                  <a:srgbClr val="FFFF00"/>
+                </a:highlight>
+              </a:rPr>
+              <a:t>squashed</a:t>
+            </a:r>
+            <a:r>
+              <a:rPr lang="en-US" sz="1050" b="1" dirty="0">
+                <a:solidFill>
+                  <a:schemeClr val="accent2"/>
+                </a:solidFill>
+              </a:rPr>
+              <a:t> to remove messy local dev history</a:t>
+            </a:r>
+          </a:p>
+        </p:txBody>
+      </p:sp>
+      <p:sp>
+        <p:nvSpPr>
+          <p:cNvPr id="128" name="Oval 127">
+            <a:extLst>
+              <a:ext uri="{FF2B5EF4-FFF2-40B4-BE49-F238E27FC236}">
+                <a16:creationId xmlns:a16="http://schemas.microsoft.com/office/drawing/2014/main" id="{332FED6B-2645-E5A6-37A7-946EAE8A71EF}"/>
+              </a:ext>
+            </a:extLst>
+          </p:cNvPr>
+          <p:cNvSpPr/>
+          <p:nvPr/>
+        </p:nvSpPr>
+        <p:spPr>
+          <a:xfrm>
+            <a:off x="6608740" y="6235596"/>
+            <a:ext cx="432532" cy="432532"/>
+          </a:xfrm>
+          <a:prstGeom prst="ellipse">
+            <a:avLst/>
+          </a:prstGeom>
+        </p:spPr>
+        <p:style>
+          <a:lnRef idx="2">
+            <a:schemeClr val="dk1"/>
+          </a:lnRef>
+          <a:fillRef idx="1">
+            <a:schemeClr val="lt1"/>
+          </a:fillRef>
+          <a:effectRef idx="0">
+            <a:schemeClr val="dk1"/>
+          </a:effectRef>
+          <a:fontRef idx="minor">
+            <a:schemeClr val="dk1"/>
+          </a:fontRef>
+        </p:style>
+        <p:txBody>
+          <a:bodyPr rtlCol="0" anchor="ctr"/>
+          <a:lstStyle/>
+          <a:p>
+            <a:pPr algn="ctr"/>
+            <a:endParaRPr lang="en-US" sz="800" b="1" dirty="0"/>
+          </a:p>
+        </p:txBody>
+      </p:sp>
+      <p:sp>
+        <p:nvSpPr>
+          <p:cNvPr id="129" name="TextBox 128">
+            <a:extLst>
+              <a:ext uri="{FF2B5EF4-FFF2-40B4-BE49-F238E27FC236}">
+                <a16:creationId xmlns:a16="http://schemas.microsoft.com/office/drawing/2014/main" id="{AE3840AB-5318-EFBA-B5FA-CBA53A434D7C}"/>
+              </a:ext>
+            </a:extLst>
+          </p:cNvPr>
+          <p:cNvSpPr txBox="1"/>
+          <p:nvPr/>
+        </p:nvSpPr>
+        <p:spPr>
+          <a:xfrm>
+            <a:off x="6617455" y="6289422"/>
+            <a:ext cx="481869" cy="338554"/>
+          </a:xfrm>
+          <a:prstGeom prst="rect">
+            <a:avLst/>
+          </a:prstGeom>
+          <a:noFill/>
+        </p:spPr>
+        <p:txBody>
+          <a:bodyPr wrap="square" rtlCol="0">
+            <a:spAutoFit/>
+          </a:bodyPr>
+          <a:lstStyle/>
+          <a:p>
+            <a:r>
+              <a:rPr lang="en-US" sz="1600" b="1" dirty="0"/>
+              <a:t>M1</a:t>
+            </a:r>
+          </a:p>
+        </p:txBody>
+      </p:sp>
+      <p:cxnSp>
+        <p:nvCxnSpPr>
+          <p:cNvPr id="130" name="Straight Arrow Connector 129">
+            <a:extLst>
+              <a:ext uri="{FF2B5EF4-FFF2-40B4-BE49-F238E27FC236}">
+                <a16:creationId xmlns:a16="http://schemas.microsoft.com/office/drawing/2014/main" id="{E485D6AA-0577-2452-303B-E0405E21B770}"/>
+              </a:ext>
+            </a:extLst>
+          </p:cNvPr>
+          <p:cNvCxnSpPr>
+            <a:cxnSpLocks/>
+            <a:stCxn id="84" idx="4"/>
+          </p:cNvCxnSpPr>
+          <p:nvPr/>
+        </p:nvCxnSpPr>
+        <p:spPr>
+          <a:xfrm>
+            <a:off x="3850406" y="3288085"/>
+            <a:ext cx="2863072" cy="2997952"/>
+          </a:xfrm>
+          <a:prstGeom prst="straightConnector1">
+            <a:avLst/>
+          </a:prstGeom>
+          <a:ln>
+            <a:solidFill>
+              <a:srgbClr val="00B0F0"/>
+            </a:solidFill>
+            <a:headEnd type="none" w="med" len="med"/>
+            <a:tailEnd type="arrow" w="med" len="med"/>
+          </a:ln>
+        </p:spPr>
+        <p:style>
+          <a:lnRef idx="3">
+            <a:schemeClr val="accent1"/>
+          </a:lnRef>
+          <a:fillRef idx="0">
+            <a:schemeClr val="accent1"/>
+          </a:fillRef>
+          <a:effectRef idx="2">
+            <a:schemeClr val="accent1"/>
+          </a:effectRef>
+          <a:fontRef idx="minor">
+            <a:schemeClr val="tx1"/>
+          </a:fontRef>
+        </p:style>
+      </p:cxnSp>
+      <p:sp>
+        <p:nvSpPr>
+          <p:cNvPr id="137" name="TextBox 136">
+            <a:extLst>
+              <a:ext uri="{FF2B5EF4-FFF2-40B4-BE49-F238E27FC236}">
+                <a16:creationId xmlns:a16="http://schemas.microsoft.com/office/drawing/2014/main" id="{D93D56C0-61CE-6CB5-4A60-091E2AC3FD30}"/>
+              </a:ext>
+            </a:extLst>
+          </p:cNvPr>
+          <p:cNvSpPr txBox="1"/>
+          <p:nvPr/>
+        </p:nvSpPr>
+        <p:spPr>
+          <a:xfrm rot="16200000">
+            <a:off x="3118105" y="3159328"/>
+            <a:ext cx="861774" cy="2900627"/>
+          </a:xfrm>
+          <a:prstGeom prst="rect">
+            <a:avLst/>
+          </a:prstGeom>
+          <a:noFill/>
+        </p:spPr>
+        <p:txBody>
+          <a:bodyPr vert="eaVert" wrap="square" rtlCol="0">
+            <a:spAutoFit/>
+          </a:bodyPr>
+          <a:lstStyle/>
+          <a:p>
+            <a:r>
+              <a:rPr lang="en-US" sz="1100" dirty="0">
+                <a:solidFill>
+                  <a:schemeClr val="tx2">
+                    <a:lumMod val="75000"/>
+                    <a:lumOff val="25000"/>
+                  </a:schemeClr>
+                </a:solidFill>
+              </a:rPr>
+              <a:t>Public GitHub has already progressed from O to S1, so contributor 2 needs to merge S1 into their dev to make sure their changes work together with S1 before submit a pull request.</a:t>
+            </a:r>
+          </a:p>
+        </p:txBody>
+      </p:sp>
+      <p:sp>
+        <p:nvSpPr>
+          <p:cNvPr id="138" name="Oval 137">
+            <a:extLst>
+              <a:ext uri="{FF2B5EF4-FFF2-40B4-BE49-F238E27FC236}">
+                <a16:creationId xmlns:a16="http://schemas.microsoft.com/office/drawing/2014/main" id="{6D3BF84E-3676-8A43-AD18-B0AAA6ACB4C3}"/>
+              </a:ext>
+            </a:extLst>
+          </p:cNvPr>
+          <p:cNvSpPr/>
+          <p:nvPr/>
+        </p:nvSpPr>
+        <p:spPr>
+          <a:xfrm>
+            <a:off x="7760450" y="6235596"/>
+            <a:ext cx="432532" cy="432532"/>
+          </a:xfrm>
+          <a:prstGeom prst="ellipse">
+            <a:avLst/>
+          </a:prstGeom>
+        </p:spPr>
+        <p:style>
+          <a:lnRef idx="2">
+            <a:schemeClr val="dk1"/>
+          </a:lnRef>
+          <a:fillRef idx="1">
+            <a:schemeClr val="lt1"/>
+          </a:fillRef>
+          <a:effectRef idx="0">
+            <a:schemeClr val="dk1"/>
+          </a:effectRef>
+          <a:fontRef idx="minor">
+            <a:schemeClr val="dk1"/>
+          </a:fontRef>
+        </p:style>
+        <p:txBody>
+          <a:bodyPr rtlCol="0" anchor="ctr"/>
+          <a:lstStyle/>
+          <a:p>
+            <a:pPr algn="ctr"/>
+            <a:endParaRPr lang="en-US" sz="800" b="1" dirty="0"/>
+          </a:p>
+        </p:txBody>
+      </p:sp>
+      <p:sp>
+        <p:nvSpPr>
+          <p:cNvPr id="139" name="TextBox 138">
+            <a:extLst>
+              <a:ext uri="{FF2B5EF4-FFF2-40B4-BE49-F238E27FC236}">
+                <a16:creationId xmlns:a16="http://schemas.microsoft.com/office/drawing/2014/main" id="{5AFCEFE0-1123-BBE7-FBF6-8FB95E07B552}"/>
+              </a:ext>
+            </a:extLst>
+          </p:cNvPr>
+          <p:cNvSpPr txBox="1"/>
+          <p:nvPr/>
+        </p:nvSpPr>
+        <p:spPr>
+          <a:xfrm>
+            <a:off x="7743473" y="6286037"/>
+            <a:ext cx="559726" cy="338554"/>
+          </a:xfrm>
+          <a:prstGeom prst="rect">
+            <a:avLst/>
+          </a:prstGeom>
+          <a:noFill/>
+        </p:spPr>
+        <p:txBody>
+          <a:bodyPr wrap="square" rtlCol="0">
+            <a:spAutoFit/>
+          </a:bodyPr>
+          <a:lstStyle/>
+          <a:p>
+            <a:r>
+              <a:rPr lang="en-US" sz="1600" b="1" dirty="0"/>
+              <a:t>M1’</a:t>
+            </a:r>
+          </a:p>
+        </p:txBody>
+      </p:sp>
+      <p:sp>
+        <p:nvSpPr>
+          <p:cNvPr id="140" name="TextBox 139">
+            <a:extLst>
+              <a:ext uri="{FF2B5EF4-FFF2-40B4-BE49-F238E27FC236}">
+                <a16:creationId xmlns:a16="http://schemas.microsoft.com/office/drawing/2014/main" id="{CD3282E3-E723-7DE9-24F5-1401856CD60B}"/>
+              </a:ext>
+            </a:extLst>
+          </p:cNvPr>
+          <p:cNvSpPr txBox="1"/>
+          <p:nvPr/>
+        </p:nvSpPr>
+        <p:spPr>
+          <a:xfrm>
+            <a:off x="6954738" y="6217141"/>
+            <a:ext cx="909223" cy="253916"/>
+          </a:xfrm>
+          <a:prstGeom prst="rect">
+            <a:avLst/>
+          </a:prstGeom>
+          <a:noFill/>
+        </p:spPr>
+        <p:txBody>
+          <a:bodyPr wrap="square" rtlCol="0">
+            <a:spAutoFit/>
+          </a:bodyPr>
+          <a:lstStyle/>
+          <a:p>
+            <a:r>
+              <a:rPr lang="en-US" sz="1050" dirty="0"/>
+              <a:t>Fix if needed</a:t>
+            </a:r>
+          </a:p>
+        </p:txBody>
+      </p:sp>
+      <p:cxnSp>
+        <p:nvCxnSpPr>
+          <p:cNvPr id="141" name="Straight Arrow Connector 140">
+            <a:extLst>
+              <a:ext uri="{FF2B5EF4-FFF2-40B4-BE49-F238E27FC236}">
+                <a16:creationId xmlns:a16="http://schemas.microsoft.com/office/drawing/2014/main" id="{41599EA9-D1BB-E45E-BB31-A34FC0EAB0ED}"/>
+              </a:ext>
+            </a:extLst>
+          </p:cNvPr>
+          <p:cNvCxnSpPr>
+            <a:cxnSpLocks/>
+            <a:stCxn id="138" idx="0"/>
+            <a:endCxn id="146" idx="4"/>
+          </p:cNvCxnSpPr>
+          <p:nvPr/>
+        </p:nvCxnSpPr>
+        <p:spPr>
+          <a:xfrm flipV="1">
+            <a:off x="7976716" y="3284403"/>
+            <a:ext cx="342452" cy="2951193"/>
+          </a:xfrm>
+          <a:prstGeom prst="straightConnector1">
+            <a:avLst/>
+          </a:prstGeom>
+          <a:ln w="28575" cap="flat" cmpd="sng" algn="ctr">
+            <a:solidFill>
+              <a:schemeClr val="accent2"/>
+            </a:solidFill>
+            <a:prstDash val="sysDot"/>
+            <a:round/>
+            <a:headEnd type="none" w="med" len="med"/>
+            <a:tailEnd type="arrow" w="med" len="med"/>
+          </a:ln>
+        </p:spPr>
+        <p:style>
+          <a:lnRef idx="0">
+            <a:scrgbClr r="0" g="0" b="0"/>
+          </a:lnRef>
+          <a:fillRef idx="0">
+            <a:scrgbClr r="0" g="0" b="0"/>
+          </a:fillRef>
+          <a:effectRef idx="0">
+            <a:scrgbClr r="0" g="0" b="0"/>
+          </a:effectRef>
+          <a:fontRef idx="minor">
+            <a:schemeClr val="tx1"/>
+          </a:fontRef>
+        </p:style>
+      </p:cxnSp>
+      <p:sp>
+        <p:nvSpPr>
+          <p:cNvPr id="146" name="Oval 145">
+            <a:extLst>
+              <a:ext uri="{FF2B5EF4-FFF2-40B4-BE49-F238E27FC236}">
+                <a16:creationId xmlns:a16="http://schemas.microsoft.com/office/drawing/2014/main" id="{8C3F31E5-D7F2-8012-3BC9-F2B389CB8D4C}"/>
+              </a:ext>
+            </a:extLst>
+          </p:cNvPr>
+          <p:cNvSpPr/>
+          <p:nvPr/>
+        </p:nvSpPr>
+        <p:spPr>
+          <a:xfrm>
+            <a:off x="8102902" y="2851871"/>
+            <a:ext cx="432532" cy="432532"/>
+          </a:xfrm>
+          <a:prstGeom prst="ellipse">
+            <a:avLst/>
+          </a:prstGeom>
+        </p:spPr>
+        <p:style>
+          <a:lnRef idx="2">
+            <a:schemeClr val="dk1"/>
+          </a:lnRef>
+          <a:fillRef idx="1">
+            <a:schemeClr val="lt1"/>
+          </a:fillRef>
+          <a:effectRef idx="0">
+            <a:schemeClr val="dk1"/>
+          </a:effectRef>
+          <a:fontRef idx="minor">
+            <a:schemeClr val="dk1"/>
+          </a:fontRef>
+        </p:style>
+        <p:txBody>
+          <a:bodyPr rtlCol="0" anchor="ctr"/>
+          <a:lstStyle/>
+          <a:p>
+            <a:pPr algn="ctr"/>
+            <a:endParaRPr lang="en-US" sz="800" b="1" dirty="0"/>
+          </a:p>
+        </p:txBody>
+      </p:sp>
+      <p:sp>
+        <p:nvSpPr>
+          <p:cNvPr id="147" name="TextBox 146">
+            <a:extLst>
+              <a:ext uri="{FF2B5EF4-FFF2-40B4-BE49-F238E27FC236}">
+                <a16:creationId xmlns:a16="http://schemas.microsoft.com/office/drawing/2014/main" id="{49C4FD98-250A-8D94-0C3F-6758534ABC1F}"/>
+              </a:ext>
+            </a:extLst>
+          </p:cNvPr>
+          <p:cNvSpPr txBox="1"/>
+          <p:nvPr/>
+        </p:nvSpPr>
+        <p:spPr>
+          <a:xfrm>
+            <a:off x="8109650" y="2905697"/>
+            <a:ext cx="481869" cy="338554"/>
+          </a:xfrm>
+          <a:prstGeom prst="rect">
+            <a:avLst/>
+          </a:prstGeom>
+          <a:noFill/>
+        </p:spPr>
+        <p:txBody>
+          <a:bodyPr wrap="square" rtlCol="0">
+            <a:spAutoFit/>
+          </a:bodyPr>
+          <a:lstStyle/>
+          <a:p>
+            <a:r>
+              <a:rPr lang="en-US" sz="1600" b="1" dirty="0"/>
+              <a:t>S3</a:t>
+            </a:r>
+          </a:p>
+        </p:txBody>
+      </p:sp>
+      <p:sp>
+        <p:nvSpPr>
+          <p:cNvPr id="148" name="TextBox 147">
+            <a:extLst>
+              <a:ext uri="{FF2B5EF4-FFF2-40B4-BE49-F238E27FC236}">
+                <a16:creationId xmlns:a16="http://schemas.microsoft.com/office/drawing/2014/main" id="{E6D434C4-2277-4428-5747-2F34B286949E}"/>
+              </a:ext>
+            </a:extLst>
+          </p:cNvPr>
+          <p:cNvSpPr txBox="1"/>
+          <p:nvPr/>
+        </p:nvSpPr>
+        <p:spPr>
+          <a:xfrm rot="16200000">
+            <a:off x="8420859" y="4461828"/>
+            <a:ext cx="1369606" cy="1818831"/>
+          </a:xfrm>
+          <a:prstGeom prst="rect">
+            <a:avLst/>
+          </a:prstGeom>
+          <a:noFill/>
+        </p:spPr>
+        <p:txBody>
+          <a:bodyPr vert="eaVert" wrap="square" rtlCol="0">
+            <a:spAutoFit/>
+          </a:bodyPr>
+          <a:lstStyle/>
+          <a:p>
+            <a:r>
+              <a:rPr lang="en-US" sz="1100" dirty="0"/>
+              <a:t>Pull Request.</a:t>
+            </a:r>
+          </a:p>
+          <a:p>
+            <a:r>
+              <a:rPr lang="en-US" sz="1100" dirty="0"/>
+              <a:t>To keep GitHub history clear, we accept PR with </a:t>
+            </a:r>
+            <a:r>
+              <a:rPr lang="en-US" sz="1100" dirty="0">
+                <a:highlight>
+                  <a:srgbClr val="FFFF00"/>
+                </a:highlight>
+              </a:rPr>
+              <a:t>squash</a:t>
+            </a:r>
+            <a:r>
+              <a:rPr lang="en-US" sz="1100" dirty="0"/>
+              <a:t> merge. S3 included all squashed changes from D to M1’, but it only has one parent S1</a:t>
+            </a:r>
+          </a:p>
+        </p:txBody>
+      </p:sp>
+      <p:sp>
+        <p:nvSpPr>
+          <p:cNvPr id="162" name="Oval 161">
+            <a:extLst>
+              <a:ext uri="{FF2B5EF4-FFF2-40B4-BE49-F238E27FC236}">
+                <a16:creationId xmlns:a16="http://schemas.microsoft.com/office/drawing/2014/main" id="{95478DD8-1DC9-36DA-342C-955F8B3830B9}"/>
+              </a:ext>
+            </a:extLst>
+          </p:cNvPr>
+          <p:cNvSpPr/>
+          <p:nvPr/>
+        </p:nvSpPr>
+        <p:spPr>
+          <a:xfrm>
+            <a:off x="7009845" y="651669"/>
+            <a:ext cx="432532" cy="432532"/>
+          </a:xfrm>
+          <a:prstGeom prst="ellipse">
+            <a:avLst/>
+          </a:prstGeom>
+        </p:spPr>
+        <p:style>
+          <a:lnRef idx="2">
+            <a:schemeClr val="dk1"/>
+          </a:lnRef>
+          <a:fillRef idx="1">
+            <a:schemeClr val="lt1"/>
+          </a:fillRef>
+          <a:effectRef idx="0">
+            <a:schemeClr val="dk1"/>
+          </a:effectRef>
+          <a:fontRef idx="minor">
+            <a:schemeClr val="dk1"/>
+          </a:fontRef>
+        </p:style>
+        <p:txBody>
+          <a:bodyPr rtlCol="0" anchor="ctr"/>
+          <a:lstStyle/>
+          <a:p>
+            <a:pPr algn="ctr"/>
+            <a:r>
+              <a:rPr lang="en-US" sz="2000" b="1" dirty="0"/>
+              <a:t>I</a:t>
+            </a:r>
+          </a:p>
+        </p:txBody>
+      </p:sp>
+      <p:sp>
+        <p:nvSpPr>
+          <p:cNvPr id="163" name="Oval 162">
+            <a:extLst>
+              <a:ext uri="{FF2B5EF4-FFF2-40B4-BE49-F238E27FC236}">
+                <a16:creationId xmlns:a16="http://schemas.microsoft.com/office/drawing/2014/main" id="{376369BF-7259-368D-26F5-227F28AEBE41}"/>
+              </a:ext>
+            </a:extLst>
+          </p:cNvPr>
+          <p:cNvSpPr/>
+          <p:nvPr/>
+        </p:nvSpPr>
+        <p:spPr>
+          <a:xfrm>
+            <a:off x="8733294" y="672983"/>
+            <a:ext cx="432532" cy="432532"/>
+          </a:xfrm>
+          <a:prstGeom prst="ellipse">
+            <a:avLst/>
+          </a:prstGeom>
+        </p:spPr>
+        <p:style>
+          <a:lnRef idx="2">
+            <a:schemeClr val="dk1"/>
+          </a:lnRef>
+          <a:fillRef idx="1">
+            <a:schemeClr val="lt1"/>
+          </a:fillRef>
+          <a:effectRef idx="0">
+            <a:schemeClr val="dk1"/>
+          </a:effectRef>
+          <a:fontRef idx="minor">
+            <a:schemeClr val="dk1"/>
+          </a:fontRef>
+        </p:style>
+        <p:txBody>
+          <a:bodyPr rtlCol="0" anchor="ctr"/>
+          <a:lstStyle/>
+          <a:p>
+            <a:pPr algn="ctr"/>
+            <a:r>
+              <a:rPr lang="en-US" sz="2000" b="1" dirty="0"/>
+              <a:t>J</a:t>
+            </a:r>
+          </a:p>
+        </p:txBody>
+      </p:sp>
+      <p:sp>
+        <p:nvSpPr>
+          <p:cNvPr id="165" name="TextBox 164">
+            <a:extLst>
+              <a:ext uri="{FF2B5EF4-FFF2-40B4-BE49-F238E27FC236}">
+                <a16:creationId xmlns:a16="http://schemas.microsoft.com/office/drawing/2014/main" id="{A5752DC9-5D31-28E1-D15A-91F83748A188}"/>
+              </a:ext>
+            </a:extLst>
+          </p:cNvPr>
+          <p:cNvSpPr txBox="1"/>
+          <p:nvPr/>
+        </p:nvSpPr>
+        <p:spPr>
+          <a:xfrm rot="16200000">
+            <a:off x="7548348" y="49890"/>
+            <a:ext cx="954107" cy="2995325"/>
+          </a:xfrm>
+          <a:prstGeom prst="rect">
+            <a:avLst/>
+          </a:prstGeom>
+          <a:noFill/>
+        </p:spPr>
+        <p:txBody>
+          <a:bodyPr vert="eaVert" wrap="square" rtlCol="0">
+            <a:spAutoFit/>
+          </a:bodyPr>
+          <a:lstStyle/>
+          <a:p>
+            <a:r>
+              <a:rPr lang="en-US" sz="1000" dirty="0"/>
+              <a:t>Contributor can fetch and merge S3 to their develop branch, so that they work with the latest code. (They need to do this carefully, since public settings may not match their local ones. But ideally, local specific env settings should not go to a collaborative repo)</a:t>
+            </a:r>
+          </a:p>
+        </p:txBody>
+      </p:sp>
+      <p:sp>
+        <p:nvSpPr>
+          <p:cNvPr id="167" name="Oval 166">
+            <a:extLst>
+              <a:ext uri="{FF2B5EF4-FFF2-40B4-BE49-F238E27FC236}">
+                <a16:creationId xmlns:a16="http://schemas.microsoft.com/office/drawing/2014/main" id="{26B66FFE-96B2-8214-4907-6E92AC782640}"/>
+              </a:ext>
+            </a:extLst>
+          </p:cNvPr>
+          <p:cNvSpPr/>
+          <p:nvPr/>
+        </p:nvSpPr>
+        <p:spPr>
+          <a:xfrm>
+            <a:off x="9798811" y="1766594"/>
+            <a:ext cx="432532" cy="432532"/>
+          </a:xfrm>
+          <a:prstGeom prst="ellipse">
+            <a:avLst/>
+          </a:prstGeom>
+        </p:spPr>
+        <p:style>
+          <a:lnRef idx="2">
+            <a:schemeClr val="dk1"/>
+          </a:lnRef>
+          <a:fillRef idx="1">
+            <a:schemeClr val="lt1"/>
+          </a:fillRef>
+          <a:effectRef idx="0">
+            <a:schemeClr val="dk1"/>
+          </a:effectRef>
+          <a:fontRef idx="minor">
+            <a:schemeClr val="dk1"/>
+          </a:fontRef>
+        </p:style>
+        <p:txBody>
+          <a:bodyPr rtlCol="0" anchor="ctr"/>
+          <a:lstStyle/>
+          <a:p>
+            <a:pPr algn="ctr"/>
+            <a:endParaRPr lang="en-US" sz="2000" b="1" dirty="0"/>
+          </a:p>
+        </p:txBody>
+      </p:sp>
+      <p:cxnSp>
+        <p:nvCxnSpPr>
+          <p:cNvPr id="168" name="Straight Arrow Connector 167">
+            <a:extLst>
+              <a:ext uri="{FF2B5EF4-FFF2-40B4-BE49-F238E27FC236}">
+                <a16:creationId xmlns:a16="http://schemas.microsoft.com/office/drawing/2014/main" id="{630C0076-64F1-FC52-0264-FE16CA1D00C8}"/>
+              </a:ext>
+            </a:extLst>
+          </p:cNvPr>
+          <p:cNvCxnSpPr>
+            <a:cxnSpLocks/>
+            <a:endCxn id="167" idx="1"/>
+          </p:cNvCxnSpPr>
+          <p:nvPr/>
+        </p:nvCxnSpPr>
+        <p:spPr>
+          <a:xfrm>
+            <a:off x="9165826" y="1078433"/>
+            <a:ext cx="696328" cy="751504"/>
+          </a:xfrm>
+          <a:prstGeom prst="straightConnector1">
+            <a:avLst/>
+          </a:prstGeom>
+          <a:ln w="28575" cap="flat" cmpd="sng" algn="ctr">
+            <a:solidFill>
+              <a:schemeClr val="accent2"/>
+            </a:solidFill>
+            <a:prstDash val="sysDot"/>
+            <a:round/>
+            <a:headEnd type="none" w="med" len="med"/>
+            <a:tailEnd type="arrow" w="med" len="med"/>
+          </a:ln>
+        </p:spPr>
+        <p:style>
+          <a:lnRef idx="0">
+            <a:scrgbClr r="0" g="0" b="0"/>
+          </a:lnRef>
+          <a:fillRef idx="0">
+            <a:scrgbClr r="0" g="0" b="0"/>
+          </a:fillRef>
+          <a:effectRef idx="0">
+            <a:scrgbClr r="0" g="0" b="0"/>
+          </a:effectRef>
+          <a:fontRef idx="minor">
+            <a:schemeClr val="tx1"/>
+          </a:fontRef>
+        </p:style>
+      </p:cxnSp>
+      <p:sp>
+        <p:nvSpPr>
+          <p:cNvPr id="173" name="TextBox 172">
+            <a:extLst>
+              <a:ext uri="{FF2B5EF4-FFF2-40B4-BE49-F238E27FC236}">
+                <a16:creationId xmlns:a16="http://schemas.microsoft.com/office/drawing/2014/main" id="{6B49B810-2582-B4B8-CFEF-25C22D4BF5DC}"/>
+              </a:ext>
+            </a:extLst>
+          </p:cNvPr>
+          <p:cNvSpPr txBox="1"/>
+          <p:nvPr/>
+        </p:nvSpPr>
+        <p:spPr>
+          <a:xfrm>
+            <a:off x="9798811" y="1818923"/>
+            <a:ext cx="481869" cy="338554"/>
+          </a:xfrm>
+          <a:prstGeom prst="rect">
+            <a:avLst/>
+          </a:prstGeom>
+          <a:noFill/>
+        </p:spPr>
+        <p:txBody>
+          <a:bodyPr wrap="square" rtlCol="0">
+            <a:spAutoFit/>
+          </a:bodyPr>
+          <a:lstStyle/>
+          <a:p>
+            <a:r>
+              <a:rPr lang="en-US" sz="1600" b="1" dirty="0"/>
+              <a:t>S4</a:t>
+            </a:r>
+          </a:p>
+        </p:txBody>
+      </p:sp>
+      <p:sp>
+        <p:nvSpPr>
+          <p:cNvPr id="175" name="Oval 174">
+            <a:extLst>
+              <a:ext uri="{FF2B5EF4-FFF2-40B4-BE49-F238E27FC236}">
+                <a16:creationId xmlns:a16="http://schemas.microsoft.com/office/drawing/2014/main" id="{B25EE8F1-3A99-D2C1-328D-89259F8E3A3B}"/>
+              </a:ext>
+            </a:extLst>
+          </p:cNvPr>
+          <p:cNvSpPr/>
+          <p:nvPr/>
+        </p:nvSpPr>
+        <p:spPr>
+          <a:xfrm>
+            <a:off x="11075322" y="1772761"/>
+            <a:ext cx="432532" cy="432532"/>
+          </a:xfrm>
+          <a:prstGeom prst="ellipse">
+            <a:avLst/>
+          </a:prstGeom>
+        </p:spPr>
+        <p:style>
+          <a:lnRef idx="2">
+            <a:schemeClr val="dk1"/>
+          </a:lnRef>
+          <a:fillRef idx="1">
+            <a:schemeClr val="lt1"/>
+          </a:fillRef>
+          <a:effectRef idx="0">
+            <a:schemeClr val="dk1"/>
+          </a:effectRef>
+          <a:fontRef idx="minor">
+            <a:schemeClr val="dk1"/>
+          </a:fontRef>
+        </p:style>
+        <p:txBody>
+          <a:bodyPr rtlCol="0" anchor="ctr"/>
+          <a:lstStyle/>
+          <a:p>
+            <a:pPr algn="ctr"/>
+            <a:endParaRPr lang="en-US" sz="800" b="1" dirty="0"/>
+          </a:p>
+        </p:txBody>
+      </p:sp>
+      <p:sp>
+        <p:nvSpPr>
+          <p:cNvPr id="176" name="TextBox 175">
+            <a:extLst>
+              <a:ext uri="{FF2B5EF4-FFF2-40B4-BE49-F238E27FC236}">
+                <a16:creationId xmlns:a16="http://schemas.microsoft.com/office/drawing/2014/main" id="{E9CA5A27-7DE3-51FE-760F-D7EC07DAF56A}"/>
+              </a:ext>
+            </a:extLst>
+          </p:cNvPr>
+          <p:cNvSpPr txBox="1"/>
+          <p:nvPr/>
+        </p:nvSpPr>
+        <p:spPr>
+          <a:xfrm>
+            <a:off x="11084037" y="1826587"/>
+            <a:ext cx="481869" cy="338554"/>
+          </a:xfrm>
+          <a:prstGeom prst="rect">
+            <a:avLst/>
+          </a:prstGeom>
+          <a:noFill/>
+        </p:spPr>
+        <p:txBody>
+          <a:bodyPr wrap="square" rtlCol="0">
+            <a:spAutoFit/>
+          </a:bodyPr>
+          <a:lstStyle/>
+          <a:p>
+            <a:r>
+              <a:rPr lang="en-US" sz="1600" b="1" dirty="0"/>
+              <a:t>M2</a:t>
+            </a:r>
+          </a:p>
+        </p:txBody>
+      </p:sp>
+      <p:sp>
+        <p:nvSpPr>
+          <p:cNvPr id="177" name="TextBox 176">
+            <a:extLst>
+              <a:ext uri="{FF2B5EF4-FFF2-40B4-BE49-F238E27FC236}">
+                <a16:creationId xmlns:a16="http://schemas.microsoft.com/office/drawing/2014/main" id="{EE479025-6AFF-2F9A-BB7C-CD36C3C6253B}"/>
+              </a:ext>
+            </a:extLst>
+          </p:cNvPr>
+          <p:cNvSpPr txBox="1"/>
+          <p:nvPr/>
+        </p:nvSpPr>
+        <p:spPr>
+          <a:xfrm rot="16200000">
+            <a:off x="10144174" y="683989"/>
+            <a:ext cx="369332" cy="1404651"/>
+          </a:xfrm>
+          <a:prstGeom prst="rect">
+            <a:avLst/>
+          </a:prstGeom>
+          <a:noFill/>
+        </p:spPr>
+        <p:txBody>
+          <a:bodyPr vert="eaVert" wrap="square" rtlCol="0">
+            <a:spAutoFit/>
+          </a:bodyPr>
+          <a:lstStyle/>
+          <a:p>
+            <a:r>
+              <a:rPr lang="en-US" sz="1200" dirty="0">
+                <a:solidFill>
+                  <a:schemeClr val="accent2"/>
+                </a:solidFill>
+              </a:rPr>
+              <a:t>Squash merge</a:t>
+            </a:r>
+          </a:p>
+        </p:txBody>
+      </p:sp>
+      <p:cxnSp>
+        <p:nvCxnSpPr>
+          <p:cNvPr id="178" name="Straight Arrow Connector 177">
+            <a:extLst>
+              <a:ext uri="{FF2B5EF4-FFF2-40B4-BE49-F238E27FC236}">
+                <a16:creationId xmlns:a16="http://schemas.microsoft.com/office/drawing/2014/main" id="{3478F208-C998-993A-35C9-325EE65CC686}"/>
+              </a:ext>
+            </a:extLst>
+          </p:cNvPr>
+          <p:cNvCxnSpPr>
+            <a:cxnSpLocks/>
+          </p:cNvCxnSpPr>
+          <p:nvPr/>
+        </p:nvCxnSpPr>
+        <p:spPr>
+          <a:xfrm flipV="1">
+            <a:off x="8470209" y="2154773"/>
+            <a:ext cx="2631993" cy="747243"/>
+          </a:xfrm>
+          <a:prstGeom prst="straightConnector1">
+            <a:avLst/>
+          </a:prstGeom>
+          <a:ln>
+            <a:solidFill>
+              <a:srgbClr val="00B0F0"/>
+            </a:solidFill>
+            <a:headEnd type="none" w="med" len="med"/>
+            <a:tailEnd type="arrow" w="med" len="med"/>
+          </a:ln>
+        </p:spPr>
+        <p:style>
+          <a:lnRef idx="3">
+            <a:schemeClr val="accent1"/>
+          </a:lnRef>
+          <a:fillRef idx="0">
+            <a:schemeClr val="accent1"/>
+          </a:fillRef>
+          <a:effectRef idx="2">
+            <a:schemeClr val="accent1"/>
+          </a:effectRef>
+          <a:fontRef idx="minor">
+            <a:schemeClr val="tx1"/>
+          </a:fontRef>
+        </p:style>
+      </p:cxnSp>
+      <p:sp>
+        <p:nvSpPr>
+          <p:cNvPr id="182" name="TextBox 181">
+            <a:extLst>
+              <a:ext uri="{FF2B5EF4-FFF2-40B4-BE49-F238E27FC236}">
+                <a16:creationId xmlns:a16="http://schemas.microsoft.com/office/drawing/2014/main" id="{EA9FAC2E-BA5C-46C8-27A0-33D33F63AB7A}"/>
+              </a:ext>
+            </a:extLst>
+          </p:cNvPr>
+          <p:cNvSpPr txBox="1"/>
+          <p:nvPr/>
+        </p:nvSpPr>
+        <p:spPr>
+          <a:xfrm rot="16200000">
+            <a:off x="10252715" y="830549"/>
+            <a:ext cx="507831" cy="3355914"/>
+          </a:xfrm>
+          <a:prstGeom prst="rect">
+            <a:avLst/>
+          </a:prstGeom>
+          <a:noFill/>
+        </p:spPr>
+        <p:txBody>
+          <a:bodyPr vert="eaVert" wrap="square" rtlCol="0">
+            <a:spAutoFit/>
+          </a:bodyPr>
+          <a:lstStyle/>
+          <a:p>
+            <a:r>
+              <a:rPr lang="en-US" sz="1050" dirty="0"/>
+              <a:t>Merge S3 into S4, resolve conflicts,</a:t>
+            </a:r>
+          </a:p>
+          <a:p>
+            <a:r>
+              <a:rPr lang="en-US" sz="1050" dirty="0"/>
+              <a:t>compile and test. If work, submit PR</a:t>
+            </a:r>
+          </a:p>
+        </p:txBody>
+      </p:sp>
+      <p:sp>
+        <p:nvSpPr>
+          <p:cNvPr id="186" name="TextBox 185">
+            <a:extLst>
+              <a:ext uri="{FF2B5EF4-FFF2-40B4-BE49-F238E27FC236}">
+                <a16:creationId xmlns:a16="http://schemas.microsoft.com/office/drawing/2014/main" id="{5FE9B3A3-B155-3BE2-A33E-E0148FF49420}"/>
+              </a:ext>
+            </a:extLst>
+          </p:cNvPr>
+          <p:cNvSpPr txBox="1"/>
+          <p:nvPr/>
+        </p:nvSpPr>
+        <p:spPr>
+          <a:xfrm rot="16200000">
+            <a:off x="12805191" y="829446"/>
+            <a:ext cx="1031051" cy="3481925"/>
+          </a:xfrm>
+          <a:prstGeom prst="rect">
+            <a:avLst/>
+          </a:prstGeom>
+          <a:noFill/>
+        </p:spPr>
+        <p:txBody>
+          <a:bodyPr vert="eaVert" wrap="square" rtlCol="0">
+            <a:spAutoFit/>
+          </a:bodyPr>
+          <a:lstStyle/>
+          <a:p>
+            <a:r>
+              <a:rPr lang="en-US" sz="1100" dirty="0"/>
+              <a:t>Pull Request. If we use Squash merge to accept PR, which always creates a new commit (S5). If we wish to continue working on </a:t>
+            </a:r>
+            <a:r>
+              <a:rPr lang="en-US" sz="1100" dirty="0" err="1"/>
+              <a:t>ForGitHub</a:t>
+            </a:r>
+            <a:r>
+              <a:rPr lang="en-US" sz="1100" dirty="0"/>
+              <a:t> branch (make it long-lived), we should use a regular merge here (S5 will be M2 in this case)</a:t>
+            </a:r>
+          </a:p>
+        </p:txBody>
+      </p:sp>
+      <p:sp>
+        <p:nvSpPr>
+          <p:cNvPr id="189" name="Oval 188">
+            <a:extLst>
+              <a:ext uri="{FF2B5EF4-FFF2-40B4-BE49-F238E27FC236}">
+                <a16:creationId xmlns:a16="http://schemas.microsoft.com/office/drawing/2014/main" id="{581848C1-E4F6-193E-E116-2B2A01E96066}"/>
+              </a:ext>
+            </a:extLst>
+          </p:cNvPr>
+          <p:cNvSpPr/>
+          <p:nvPr/>
+        </p:nvSpPr>
+        <p:spPr>
+          <a:xfrm>
+            <a:off x="11095454" y="2880252"/>
+            <a:ext cx="432532" cy="432532"/>
+          </a:xfrm>
+          <a:prstGeom prst="ellipse">
+            <a:avLst/>
+          </a:prstGeom>
+        </p:spPr>
+        <p:style>
+          <a:lnRef idx="2">
+            <a:schemeClr val="dk1"/>
+          </a:lnRef>
+          <a:fillRef idx="1">
+            <a:schemeClr val="lt1"/>
+          </a:fillRef>
+          <a:effectRef idx="0">
+            <a:schemeClr val="dk1"/>
+          </a:effectRef>
+          <a:fontRef idx="minor">
+            <a:schemeClr val="dk1"/>
+          </a:fontRef>
+        </p:style>
+        <p:txBody>
+          <a:bodyPr rtlCol="0" anchor="ctr"/>
+          <a:lstStyle/>
+          <a:p>
+            <a:pPr algn="ctr"/>
+            <a:endParaRPr lang="en-US" sz="800" b="1" dirty="0"/>
+          </a:p>
+        </p:txBody>
+      </p:sp>
+      <p:sp>
+        <p:nvSpPr>
+          <p:cNvPr id="190" name="TextBox 189">
+            <a:extLst>
+              <a:ext uri="{FF2B5EF4-FFF2-40B4-BE49-F238E27FC236}">
+                <a16:creationId xmlns:a16="http://schemas.microsoft.com/office/drawing/2014/main" id="{A829F54B-6BC7-6E9B-2F11-3581C4AD0D3A}"/>
+              </a:ext>
+            </a:extLst>
+          </p:cNvPr>
+          <p:cNvSpPr txBox="1"/>
+          <p:nvPr/>
+        </p:nvSpPr>
+        <p:spPr>
+          <a:xfrm>
+            <a:off x="11102202" y="2934078"/>
+            <a:ext cx="481869" cy="338554"/>
+          </a:xfrm>
+          <a:prstGeom prst="rect">
+            <a:avLst/>
+          </a:prstGeom>
+          <a:noFill/>
+        </p:spPr>
+        <p:txBody>
+          <a:bodyPr wrap="square" rtlCol="0">
+            <a:spAutoFit/>
+          </a:bodyPr>
+          <a:lstStyle/>
+          <a:p>
+            <a:r>
+              <a:rPr lang="en-US" sz="1600" b="1" dirty="0"/>
+              <a:t>S5</a:t>
+            </a:r>
+          </a:p>
+        </p:txBody>
+      </p:sp>
+      <p:cxnSp>
+        <p:nvCxnSpPr>
+          <p:cNvPr id="191" name="Straight Arrow Connector 190">
+            <a:extLst>
+              <a:ext uri="{FF2B5EF4-FFF2-40B4-BE49-F238E27FC236}">
+                <a16:creationId xmlns:a16="http://schemas.microsoft.com/office/drawing/2014/main" id="{5A3833DA-2846-836C-1226-F4EE388A2ACB}"/>
+              </a:ext>
+            </a:extLst>
+          </p:cNvPr>
+          <p:cNvCxnSpPr>
+            <a:cxnSpLocks/>
+            <a:stCxn id="175" idx="4"/>
+            <a:endCxn id="189" idx="0"/>
+          </p:cNvCxnSpPr>
+          <p:nvPr/>
+        </p:nvCxnSpPr>
+        <p:spPr>
+          <a:xfrm>
+            <a:off x="11291588" y="2205293"/>
+            <a:ext cx="20132" cy="674959"/>
+          </a:xfrm>
+          <a:prstGeom prst="straightConnector1">
+            <a:avLst/>
+          </a:prstGeom>
+          <a:ln w="28575" cap="flat" cmpd="sng" algn="ctr">
+            <a:solidFill>
+              <a:schemeClr val="accent2"/>
+            </a:solidFill>
+            <a:prstDash val="sysDot"/>
+            <a:round/>
+            <a:headEnd type="none" w="med" len="med"/>
+            <a:tailEnd type="arrow" w="med" len="med"/>
+          </a:ln>
+        </p:spPr>
+        <p:style>
+          <a:lnRef idx="0">
+            <a:scrgbClr r="0" g="0" b="0"/>
+          </a:lnRef>
+          <a:fillRef idx="0">
+            <a:scrgbClr r="0" g="0" b="0"/>
+          </a:fillRef>
+          <a:effectRef idx="0">
+            <a:scrgbClr r="0" g="0" b="0"/>
+          </a:effectRef>
+          <a:fontRef idx="minor">
+            <a:schemeClr val="tx1"/>
+          </a:fontRef>
+        </p:style>
+      </p:cxnSp>
+      <p:sp>
+        <p:nvSpPr>
+          <p:cNvPr id="4" name="Rectangle: Rounded Corners 3">
+            <a:extLst>
+              <a:ext uri="{FF2B5EF4-FFF2-40B4-BE49-F238E27FC236}">
+                <a16:creationId xmlns:a16="http://schemas.microsoft.com/office/drawing/2014/main" id="{FBD964AF-D7A0-D8B5-97B6-1325502BCB92}"/>
+              </a:ext>
+            </a:extLst>
+          </p:cNvPr>
+          <p:cNvSpPr/>
+          <p:nvPr/>
+        </p:nvSpPr>
+        <p:spPr>
+          <a:xfrm rot="5400000">
+            <a:off x="14817236" y="926124"/>
+            <a:ext cx="2016255" cy="640682"/>
+          </a:xfrm>
+          <a:prstGeom prst="roundRect">
+            <a:avLst/>
+          </a:prstGeom>
+          <a:solidFill>
+            <a:schemeClr val="dk1">
+              <a:alpha val="50000"/>
+            </a:schemeClr>
+          </a:solidFill>
+          <a:ln>
+            <a:noFill/>
+          </a:ln>
+        </p:spPr>
+        <p:style>
+          <a:lnRef idx="0">
+            <a:scrgbClr r="0" g="0" b="0"/>
+          </a:lnRef>
+          <a:fillRef idx="0">
+            <a:scrgbClr r="0" g="0" b="0"/>
+          </a:fillRef>
+          <a:effectRef idx="0">
+            <a:scrgbClr r="0" g="0" b="0"/>
+          </a:effectRef>
+          <a:fontRef idx="minor">
+            <a:schemeClr val="lt1"/>
+          </a:fontRef>
+        </p:style>
+        <p:txBody>
+          <a:bodyPr rtlCol="0" anchor="ctr"/>
+          <a:lstStyle/>
+          <a:p>
+            <a:pPr algn="ctr"/>
+            <a:r>
+              <a:rPr lang="en-US" dirty="0"/>
+              <a:t>Contributor 1</a:t>
+            </a:r>
+            <a:br>
+              <a:rPr lang="en-US" dirty="0"/>
+            </a:br>
+            <a:r>
+              <a:rPr lang="en-US" dirty="0"/>
+              <a:t>Private</a:t>
+            </a:r>
+          </a:p>
+        </p:txBody>
+      </p:sp>
+      <p:sp>
+        <p:nvSpPr>
+          <p:cNvPr id="8" name="Rectangle: Rounded Corners 7">
+            <a:extLst>
+              <a:ext uri="{FF2B5EF4-FFF2-40B4-BE49-F238E27FC236}">
+                <a16:creationId xmlns:a16="http://schemas.microsoft.com/office/drawing/2014/main" id="{F62F917F-C56D-F4EA-2A6F-CAFCC37A4057}"/>
+              </a:ext>
+            </a:extLst>
+          </p:cNvPr>
+          <p:cNvSpPr/>
+          <p:nvPr/>
+        </p:nvSpPr>
+        <p:spPr>
+          <a:xfrm rot="5400000">
+            <a:off x="14509525" y="5218097"/>
+            <a:ext cx="2631677" cy="640682"/>
+          </a:xfrm>
+          <a:prstGeom prst="roundRect">
+            <a:avLst/>
+          </a:prstGeom>
+          <a:solidFill>
+            <a:schemeClr val="dk1">
+              <a:alpha val="50000"/>
+            </a:schemeClr>
+          </a:solidFill>
+          <a:ln>
+            <a:noFill/>
+          </a:ln>
+        </p:spPr>
+        <p:style>
+          <a:lnRef idx="0">
+            <a:scrgbClr r="0" g="0" b="0"/>
+          </a:lnRef>
+          <a:fillRef idx="0">
+            <a:scrgbClr r="0" g="0" b="0"/>
+          </a:fillRef>
+          <a:effectRef idx="0">
+            <a:scrgbClr r="0" g="0" b="0"/>
+          </a:effectRef>
+          <a:fontRef idx="minor">
+            <a:schemeClr val="lt1"/>
+          </a:fontRef>
+        </p:style>
+        <p:txBody>
+          <a:bodyPr rtlCol="0" anchor="ctr"/>
+          <a:lstStyle/>
+          <a:p>
+            <a:pPr algn="ctr"/>
+            <a:r>
+              <a:rPr lang="en-US" dirty="0"/>
+              <a:t>Contributor 2</a:t>
+            </a:r>
+            <a:br>
+              <a:rPr lang="en-US" dirty="0"/>
+            </a:br>
+            <a:r>
+              <a:rPr lang="en-US" dirty="0"/>
+              <a:t>Private</a:t>
+            </a:r>
+          </a:p>
+        </p:txBody>
+      </p:sp>
+      <p:sp>
+        <p:nvSpPr>
+          <p:cNvPr id="9" name="Rectangle: Rounded Corners 8">
+            <a:extLst>
+              <a:ext uri="{FF2B5EF4-FFF2-40B4-BE49-F238E27FC236}">
+                <a16:creationId xmlns:a16="http://schemas.microsoft.com/office/drawing/2014/main" id="{D61CEF84-B9F6-3E18-FD5B-58746973B8CE}"/>
+              </a:ext>
+            </a:extLst>
+          </p:cNvPr>
+          <p:cNvSpPr/>
+          <p:nvPr/>
+        </p:nvSpPr>
+        <p:spPr>
+          <a:xfrm rot="5400000">
+            <a:off x="15238247" y="2794388"/>
+            <a:ext cx="1174233" cy="640682"/>
+          </a:xfrm>
+          <a:prstGeom prst="roundRect">
+            <a:avLst/>
+          </a:prstGeom>
+          <a:solidFill>
+            <a:schemeClr val="accent2"/>
+          </a:solidFill>
+          <a:ln>
+            <a:noFill/>
+          </a:ln>
+        </p:spPr>
+        <p:style>
+          <a:lnRef idx="0">
+            <a:scrgbClr r="0" g="0" b="0"/>
+          </a:lnRef>
+          <a:fillRef idx="0">
+            <a:scrgbClr r="0" g="0" b="0"/>
+          </a:fillRef>
+          <a:effectRef idx="0">
+            <a:scrgbClr r="0" g="0" b="0"/>
+          </a:effectRef>
+          <a:fontRef idx="minor">
+            <a:schemeClr val="lt1"/>
+          </a:fontRef>
+        </p:style>
+        <p:txBody>
+          <a:bodyPr rtlCol="0" anchor="ctr"/>
+          <a:lstStyle/>
+          <a:p>
+            <a:pPr algn="ctr"/>
+            <a:r>
+              <a:rPr lang="en-US" dirty="0"/>
+              <a:t>GitHub</a:t>
+            </a:r>
+          </a:p>
+          <a:p>
+            <a:pPr algn="ctr"/>
+            <a:r>
+              <a:rPr lang="en-US" dirty="0"/>
+              <a:t>Public</a:t>
+            </a:r>
+          </a:p>
+        </p:txBody>
+      </p:sp>
+      <p:sp>
+        <p:nvSpPr>
+          <p:cNvPr id="11" name="TextBox 10">
+            <a:extLst>
+              <a:ext uri="{FF2B5EF4-FFF2-40B4-BE49-F238E27FC236}">
+                <a16:creationId xmlns:a16="http://schemas.microsoft.com/office/drawing/2014/main" id="{F0A3328F-6F56-BCA7-CB67-B51E1BFD74B1}"/>
+              </a:ext>
+            </a:extLst>
+          </p:cNvPr>
+          <p:cNvSpPr txBox="1"/>
+          <p:nvPr/>
+        </p:nvSpPr>
+        <p:spPr>
+          <a:xfrm rot="16200000">
+            <a:off x="10161392" y="4951450"/>
+            <a:ext cx="1292662" cy="5785382"/>
+          </a:xfrm>
+          <a:prstGeom prst="rect">
+            <a:avLst/>
+          </a:prstGeom>
+          <a:noFill/>
+        </p:spPr>
+        <p:txBody>
+          <a:bodyPr vert="eaVert" wrap="square" rtlCol="0">
+            <a:spAutoFit/>
+          </a:bodyPr>
+          <a:lstStyle/>
+          <a:p>
+            <a:r>
+              <a:rPr lang="en-US" sz="1200" dirty="0"/>
+              <a:t>Caveat:</a:t>
+            </a:r>
+            <a:br>
+              <a:rPr lang="en-US" sz="1200" dirty="0"/>
+            </a:br>
+            <a:r>
+              <a:rPr lang="en-US" sz="1200" b="1" dirty="0"/>
+              <a:t>If updates entered </a:t>
+            </a:r>
+            <a:r>
+              <a:rPr lang="en-US" b="1" dirty="0"/>
+              <a:t>main (i.e. Public_GitHub)</a:t>
+            </a:r>
+            <a:r>
+              <a:rPr lang="en-US" sz="1200" b="1" dirty="0"/>
+              <a:t> via squash merge</a:t>
+            </a:r>
+          </a:p>
+          <a:p>
+            <a:r>
+              <a:rPr lang="en-US" sz="1200" dirty="0"/>
+              <a:t>Then bringing </a:t>
+            </a:r>
+            <a:r>
+              <a:rPr lang="en-US" dirty="0"/>
+              <a:t>main</a:t>
+            </a:r>
+            <a:r>
+              <a:rPr lang="en-US" sz="1200" dirty="0"/>
+              <a:t> back into a long-lived dev branches can become awkward. Git tracks commits by hash and parentage, not by “same overall effect.” </a:t>
+            </a:r>
+          </a:p>
+          <a:p>
+            <a:endParaRPr lang="en-US" sz="1200" dirty="0"/>
+          </a:p>
+        </p:txBody>
+      </p:sp>
+      <p:sp>
+        <p:nvSpPr>
+          <p:cNvPr id="17" name="TextBox 16">
+            <a:extLst>
+              <a:ext uri="{FF2B5EF4-FFF2-40B4-BE49-F238E27FC236}">
+                <a16:creationId xmlns:a16="http://schemas.microsoft.com/office/drawing/2014/main" id="{11322010-C94D-B3A6-9CE6-C8F12A7CE36C}"/>
+              </a:ext>
+            </a:extLst>
+          </p:cNvPr>
+          <p:cNvSpPr txBox="1"/>
+          <p:nvPr/>
+        </p:nvSpPr>
+        <p:spPr>
+          <a:xfrm>
+            <a:off x="3672383" y="704147"/>
+            <a:ext cx="2344967" cy="369332"/>
+          </a:xfrm>
+          <a:prstGeom prst="rect">
+            <a:avLst/>
+          </a:prstGeom>
+          <a:noFill/>
+        </p:spPr>
+        <p:txBody>
+          <a:bodyPr wrap="square" rtlCol="0">
+            <a:spAutoFit/>
+          </a:bodyPr>
+          <a:lstStyle/>
+          <a:p>
+            <a:r>
+              <a:rPr lang="en-US" sz="900" dirty="0">
+                <a:solidFill>
+                  <a:srgbClr val="FF0000"/>
+                </a:solidFill>
+              </a:rPr>
+              <a:t>Delete feature1 branch after squash merge, at least stop further development on it!</a:t>
+            </a:r>
+          </a:p>
+        </p:txBody>
+      </p:sp>
+      <p:sp>
+        <p:nvSpPr>
+          <p:cNvPr id="18" name="TextBox 17">
+            <a:extLst>
+              <a:ext uri="{FF2B5EF4-FFF2-40B4-BE49-F238E27FC236}">
+                <a16:creationId xmlns:a16="http://schemas.microsoft.com/office/drawing/2014/main" id="{4D3197B4-9F24-D6C1-68BE-DCE912FABA42}"/>
+              </a:ext>
+            </a:extLst>
+          </p:cNvPr>
+          <p:cNvSpPr txBox="1"/>
+          <p:nvPr/>
+        </p:nvSpPr>
+        <p:spPr>
+          <a:xfrm rot="20392659">
+            <a:off x="5905422" y="564236"/>
+            <a:ext cx="1532650" cy="369332"/>
+          </a:xfrm>
+          <a:prstGeom prst="rect">
+            <a:avLst/>
+          </a:prstGeom>
+          <a:noFill/>
+        </p:spPr>
+        <p:txBody>
+          <a:bodyPr wrap="square" rtlCol="0">
+            <a:spAutoFit/>
+          </a:bodyPr>
+          <a:lstStyle/>
+          <a:p>
+            <a:r>
+              <a:rPr lang="en-US" sz="900" dirty="0">
+                <a:solidFill>
+                  <a:schemeClr val="tx2">
+                    <a:lumMod val="75000"/>
+                    <a:lumOff val="25000"/>
+                  </a:schemeClr>
+                </a:solidFill>
+              </a:rPr>
+              <a:t>Branch out a new feature2</a:t>
+            </a:r>
+          </a:p>
+          <a:p>
+            <a:r>
+              <a:rPr lang="en-US" sz="900" dirty="0">
+                <a:solidFill>
+                  <a:schemeClr val="tx2">
+                    <a:lumMod val="75000"/>
+                    <a:lumOff val="25000"/>
+                  </a:schemeClr>
+                </a:solidFill>
+              </a:rPr>
+              <a:t>branch from S1</a:t>
+            </a:r>
+          </a:p>
+        </p:txBody>
+      </p:sp>
+      <p:sp>
+        <p:nvSpPr>
+          <p:cNvPr id="19" name="TextBox 18">
+            <a:extLst>
+              <a:ext uri="{FF2B5EF4-FFF2-40B4-BE49-F238E27FC236}">
+                <a16:creationId xmlns:a16="http://schemas.microsoft.com/office/drawing/2014/main" id="{F4D7129E-5C2F-4F66-D7A9-73B921D6C797}"/>
+              </a:ext>
+            </a:extLst>
+          </p:cNvPr>
+          <p:cNvSpPr txBox="1"/>
+          <p:nvPr/>
+        </p:nvSpPr>
+        <p:spPr>
+          <a:xfrm>
+            <a:off x="9235559" y="704147"/>
+            <a:ext cx="1980550" cy="369332"/>
+          </a:xfrm>
+          <a:prstGeom prst="rect">
+            <a:avLst/>
+          </a:prstGeom>
+          <a:noFill/>
+        </p:spPr>
+        <p:txBody>
+          <a:bodyPr wrap="square" rtlCol="0">
+            <a:spAutoFit/>
+          </a:bodyPr>
+          <a:lstStyle/>
+          <a:p>
+            <a:r>
+              <a:rPr lang="en-US" sz="900" dirty="0">
+                <a:solidFill>
+                  <a:srgbClr val="FF0000"/>
+                </a:solidFill>
+              </a:rPr>
+              <a:t>Delete feature2 branch or stop working on it after squash merge</a:t>
+            </a:r>
+          </a:p>
+        </p:txBody>
+      </p:sp>
+      <p:sp>
+        <p:nvSpPr>
+          <p:cNvPr id="20" name="TextBox 19">
+            <a:extLst>
+              <a:ext uri="{FF2B5EF4-FFF2-40B4-BE49-F238E27FC236}">
+                <a16:creationId xmlns:a16="http://schemas.microsoft.com/office/drawing/2014/main" id="{62DF4261-3924-784B-AC04-ED90272C83C4}"/>
+              </a:ext>
+            </a:extLst>
+          </p:cNvPr>
+          <p:cNvSpPr txBox="1"/>
+          <p:nvPr/>
+        </p:nvSpPr>
+        <p:spPr>
+          <a:xfrm>
+            <a:off x="8230728" y="209695"/>
+            <a:ext cx="2000615" cy="461665"/>
+          </a:xfrm>
+          <a:prstGeom prst="rect">
+            <a:avLst/>
+          </a:prstGeom>
+          <a:noFill/>
+        </p:spPr>
+        <p:txBody>
+          <a:bodyPr wrap="square" rtlCol="0">
+            <a:spAutoFit/>
+          </a:bodyPr>
+          <a:lstStyle/>
+          <a:p>
+            <a:r>
+              <a:rPr lang="en-US" sz="1200" dirty="0">
+                <a:solidFill>
+                  <a:srgbClr val="00B050"/>
+                </a:solidFill>
+              </a:rPr>
+              <a:t>J clean up mess in I</a:t>
+            </a:r>
+            <a:br>
+              <a:rPr lang="en-US" sz="1200" dirty="0">
+                <a:solidFill>
+                  <a:srgbClr val="00B050"/>
+                </a:solidFill>
+              </a:rPr>
+            </a:br>
+            <a:r>
+              <a:rPr lang="en-US" sz="1200" dirty="0">
+                <a:solidFill>
+                  <a:srgbClr val="00B050"/>
+                </a:solidFill>
+              </a:rPr>
+              <a:t>and ready to publish</a:t>
+            </a:r>
+          </a:p>
+        </p:txBody>
+      </p:sp>
+      <p:cxnSp>
+        <p:nvCxnSpPr>
+          <p:cNvPr id="25" name="Straight Connector 24">
+            <a:extLst>
+              <a:ext uri="{FF2B5EF4-FFF2-40B4-BE49-F238E27FC236}">
+                <a16:creationId xmlns:a16="http://schemas.microsoft.com/office/drawing/2014/main" id="{A5368CE6-1959-5926-FDE7-5491921AB53D}"/>
+              </a:ext>
+            </a:extLst>
+          </p:cNvPr>
+          <p:cNvCxnSpPr>
+            <a:cxnSpLocks/>
+          </p:cNvCxnSpPr>
+          <p:nvPr/>
+        </p:nvCxnSpPr>
+        <p:spPr>
+          <a:xfrm>
+            <a:off x="12044906" y="878938"/>
+            <a:ext cx="1788958" cy="0"/>
+          </a:xfrm>
+          <a:prstGeom prst="line">
+            <a:avLst/>
+          </a:prstGeom>
+          <a:ln w="76200">
+            <a:solidFill>
+              <a:schemeClr val="accent1">
+                <a:alpha val="50000"/>
+              </a:schemeClr>
+            </a:solidFill>
+          </a:ln>
+        </p:spPr>
+        <p:style>
+          <a:lnRef idx="3">
+            <a:schemeClr val="accent1"/>
+          </a:lnRef>
+          <a:fillRef idx="0">
+            <a:schemeClr val="accent1"/>
+          </a:fillRef>
+          <a:effectRef idx="2">
+            <a:schemeClr val="accent1"/>
+          </a:effectRef>
+          <a:fontRef idx="minor">
+            <a:schemeClr val="tx1"/>
+          </a:fontRef>
+        </p:style>
+      </p:cxnSp>
+      <p:sp>
+        <p:nvSpPr>
+          <p:cNvPr id="26" name="Oval 25">
+            <a:extLst>
+              <a:ext uri="{FF2B5EF4-FFF2-40B4-BE49-F238E27FC236}">
+                <a16:creationId xmlns:a16="http://schemas.microsoft.com/office/drawing/2014/main" id="{A1BC69C7-1A51-1EF0-681B-AB4765A3DEEC}"/>
+              </a:ext>
+            </a:extLst>
+          </p:cNvPr>
+          <p:cNvSpPr/>
+          <p:nvPr/>
+        </p:nvSpPr>
+        <p:spPr>
+          <a:xfrm>
+            <a:off x="11894149" y="651669"/>
+            <a:ext cx="432532" cy="432532"/>
+          </a:xfrm>
+          <a:prstGeom prst="ellipse">
+            <a:avLst/>
+          </a:prstGeom>
+        </p:spPr>
+        <p:style>
+          <a:lnRef idx="2">
+            <a:schemeClr val="dk1"/>
+          </a:lnRef>
+          <a:fillRef idx="1">
+            <a:schemeClr val="lt1"/>
+          </a:fillRef>
+          <a:effectRef idx="0">
+            <a:schemeClr val="dk1"/>
+          </a:effectRef>
+          <a:fontRef idx="minor">
+            <a:schemeClr val="dk1"/>
+          </a:fontRef>
+        </p:style>
+        <p:txBody>
+          <a:bodyPr rtlCol="0" anchor="ctr"/>
+          <a:lstStyle/>
+          <a:p>
+            <a:pPr algn="ctr"/>
+            <a:r>
+              <a:rPr lang="en-US" sz="2000" b="1" dirty="0"/>
+              <a:t>K</a:t>
+            </a:r>
+          </a:p>
+        </p:txBody>
+      </p:sp>
+      <p:sp>
+        <p:nvSpPr>
+          <p:cNvPr id="28" name="Oval 27">
+            <a:extLst>
+              <a:ext uri="{FF2B5EF4-FFF2-40B4-BE49-F238E27FC236}">
+                <a16:creationId xmlns:a16="http://schemas.microsoft.com/office/drawing/2014/main" id="{97FE624C-2B97-2D24-018E-AFF097D2929F}"/>
+              </a:ext>
+            </a:extLst>
+          </p:cNvPr>
+          <p:cNvSpPr/>
+          <p:nvPr/>
+        </p:nvSpPr>
+        <p:spPr>
+          <a:xfrm>
+            <a:off x="13617598" y="672983"/>
+            <a:ext cx="432532" cy="432532"/>
+          </a:xfrm>
+          <a:prstGeom prst="ellipse">
+            <a:avLst/>
+          </a:prstGeom>
+        </p:spPr>
+        <p:style>
+          <a:lnRef idx="2">
+            <a:schemeClr val="dk1"/>
+          </a:lnRef>
+          <a:fillRef idx="1">
+            <a:schemeClr val="lt1"/>
+          </a:fillRef>
+          <a:effectRef idx="0">
+            <a:schemeClr val="dk1"/>
+          </a:effectRef>
+          <a:fontRef idx="minor">
+            <a:schemeClr val="dk1"/>
+          </a:fontRef>
+        </p:style>
+        <p:txBody>
+          <a:bodyPr rtlCol="0" anchor="ctr"/>
+          <a:lstStyle/>
+          <a:p>
+            <a:pPr algn="ctr"/>
+            <a:r>
+              <a:rPr lang="en-US" sz="2000" b="1" dirty="0"/>
+              <a:t>L</a:t>
+            </a:r>
+          </a:p>
+        </p:txBody>
+      </p:sp>
+      <p:sp>
+        <p:nvSpPr>
+          <p:cNvPr id="35" name="TextBox 34">
+            <a:extLst>
+              <a:ext uri="{FF2B5EF4-FFF2-40B4-BE49-F238E27FC236}">
+                <a16:creationId xmlns:a16="http://schemas.microsoft.com/office/drawing/2014/main" id="{2773A916-F663-1C65-4C4C-6FDE212D1984}"/>
+              </a:ext>
+            </a:extLst>
+          </p:cNvPr>
+          <p:cNvSpPr txBox="1"/>
+          <p:nvPr/>
+        </p:nvSpPr>
+        <p:spPr>
+          <a:xfrm>
+            <a:off x="11978960" y="1190708"/>
+            <a:ext cx="3066798" cy="646331"/>
+          </a:xfrm>
+          <a:prstGeom prst="rect">
+            <a:avLst/>
+          </a:prstGeom>
+          <a:noFill/>
+        </p:spPr>
+        <p:txBody>
+          <a:bodyPr wrap="square" rtlCol="0">
+            <a:spAutoFit/>
+          </a:bodyPr>
+          <a:lstStyle/>
+          <a:p>
+            <a:r>
+              <a:rPr lang="en-US" sz="900" dirty="0">
+                <a:solidFill>
+                  <a:schemeClr val="tx2">
+                    <a:lumMod val="75000"/>
+                    <a:lumOff val="25000"/>
+                  </a:schemeClr>
+                </a:solidFill>
+              </a:rPr>
+              <a:t>If M2 is squashed into S5, new dev feature3 branch need to be created from S5, not M2. And development on </a:t>
+            </a:r>
+            <a:r>
+              <a:rPr lang="en-US" sz="900" dirty="0" err="1">
+                <a:solidFill>
+                  <a:schemeClr val="tx2">
+                    <a:lumMod val="75000"/>
+                    <a:lumOff val="25000"/>
+                  </a:schemeClr>
+                </a:solidFill>
+              </a:rPr>
+              <a:t>ForGitHub</a:t>
+            </a:r>
+            <a:r>
+              <a:rPr lang="en-US" sz="900" dirty="0">
+                <a:solidFill>
+                  <a:schemeClr val="tx2">
+                    <a:lumMod val="75000"/>
+                    <a:lumOff val="25000"/>
+                  </a:schemeClr>
+                </a:solidFill>
+              </a:rPr>
+              <a:t> should stop. (rule of thumb, once squash merged, no further work, new branch please)</a:t>
+            </a:r>
+          </a:p>
+        </p:txBody>
+      </p:sp>
+      <p:sp>
+        <p:nvSpPr>
+          <p:cNvPr id="41" name="TextBox 40">
+            <a:extLst>
+              <a:ext uri="{FF2B5EF4-FFF2-40B4-BE49-F238E27FC236}">
+                <a16:creationId xmlns:a16="http://schemas.microsoft.com/office/drawing/2014/main" id="{568C5ADA-678E-772D-4115-77DE9B56932A}"/>
+              </a:ext>
+            </a:extLst>
+          </p:cNvPr>
+          <p:cNvSpPr txBox="1"/>
+          <p:nvPr/>
+        </p:nvSpPr>
+        <p:spPr>
+          <a:xfrm>
+            <a:off x="1775146" y="1055538"/>
+            <a:ext cx="1255826" cy="261610"/>
+          </a:xfrm>
+          <a:prstGeom prst="rect">
+            <a:avLst/>
+          </a:prstGeom>
+          <a:noFill/>
+        </p:spPr>
+        <p:txBody>
+          <a:bodyPr wrap="square">
+            <a:spAutoFit/>
+          </a:bodyPr>
+          <a:lstStyle/>
+          <a:p>
+            <a:r>
+              <a:rPr lang="en-US" sz="1100" dirty="0">
+                <a:solidFill>
+                  <a:schemeClr val="tx2">
+                    <a:lumMod val="75000"/>
+                    <a:lumOff val="25000"/>
+                  </a:schemeClr>
+                </a:solidFill>
+              </a:rPr>
+              <a:t>branch feature1</a:t>
+            </a:r>
+          </a:p>
+        </p:txBody>
+      </p:sp>
+      <p:sp>
+        <p:nvSpPr>
+          <p:cNvPr id="42" name="TextBox 41">
+            <a:extLst>
+              <a:ext uri="{FF2B5EF4-FFF2-40B4-BE49-F238E27FC236}">
+                <a16:creationId xmlns:a16="http://schemas.microsoft.com/office/drawing/2014/main" id="{892B07BD-BF8A-B64A-AF7F-3964DAF0E53C}"/>
+              </a:ext>
+            </a:extLst>
+          </p:cNvPr>
+          <p:cNvSpPr txBox="1"/>
+          <p:nvPr/>
+        </p:nvSpPr>
+        <p:spPr>
+          <a:xfrm>
+            <a:off x="7509711" y="866498"/>
+            <a:ext cx="1255826" cy="261610"/>
+          </a:xfrm>
+          <a:prstGeom prst="rect">
+            <a:avLst/>
+          </a:prstGeom>
+          <a:noFill/>
+        </p:spPr>
+        <p:txBody>
+          <a:bodyPr wrap="square">
+            <a:spAutoFit/>
+          </a:bodyPr>
+          <a:lstStyle/>
+          <a:p>
+            <a:r>
+              <a:rPr lang="en-US" sz="1100" dirty="0">
+                <a:solidFill>
+                  <a:schemeClr val="tx2">
+                    <a:lumMod val="75000"/>
+                    <a:lumOff val="25000"/>
+                  </a:schemeClr>
+                </a:solidFill>
+              </a:rPr>
+              <a:t>branch feature2</a:t>
+            </a:r>
+          </a:p>
+        </p:txBody>
+      </p:sp>
+      <p:sp>
+        <p:nvSpPr>
+          <p:cNvPr id="43" name="TextBox 42">
+            <a:extLst>
+              <a:ext uri="{FF2B5EF4-FFF2-40B4-BE49-F238E27FC236}">
+                <a16:creationId xmlns:a16="http://schemas.microsoft.com/office/drawing/2014/main" id="{FB7CB4AB-4848-88DD-CB32-B4208018A73D}"/>
+              </a:ext>
+            </a:extLst>
+          </p:cNvPr>
+          <p:cNvSpPr txBox="1"/>
+          <p:nvPr/>
+        </p:nvSpPr>
+        <p:spPr>
+          <a:xfrm>
+            <a:off x="12386692" y="866498"/>
+            <a:ext cx="1255826" cy="261610"/>
+          </a:xfrm>
+          <a:prstGeom prst="rect">
+            <a:avLst/>
+          </a:prstGeom>
+          <a:noFill/>
+        </p:spPr>
+        <p:txBody>
+          <a:bodyPr wrap="square">
+            <a:spAutoFit/>
+          </a:bodyPr>
+          <a:lstStyle/>
+          <a:p>
+            <a:r>
+              <a:rPr lang="en-US" sz="1100" dirty="0">
+                <a:solidFill>
+                  <a:schemeClr val="tx2">
+                    <a:lumMod val="75000"/>
+                    <a:lumOff val="25000"/>
+                  </a:schemeClr>
+                </a:solidFill>
+              </a:rPr>
+              <a:t>branch feature3</a:t>
+            </a:r>
+          </a:p>
+        </p:txBody>
+      </p:sp>
+      <p:sp>
+        <p:nvSpPr>
+          <p:cNvPr id="58" name="TextBox 57">
+            <a:extLst>
+              <a:ext uri="{FF2B5EF4-FFF2-40B4-BE49-F238E27FC236}">
+                <a16:creationId xmlns:a16="http://schemas.microsoft.com/office/drawing/2014/main" id="{91EB7666-CFCE-709B-6096-9638CA7E5CDD}"/>
+              </a:ext>
+            </a:extLst>
+          </p:cNvPr>
+          <p:cNvSpPr txBox="1"/>
+          <p:nvPr/>
+        </p:nvSpPr>
+        <p:spPr>
+          <a:xfrm>
+            <a:off x="4322504" y="5739690"/>
+            <a:ext cx="2000615" cy="461665"/>
+          </a:xfrm>
+          <a:prstGeom prst="rect">
+            <a:avLst/>
+          </a:prstGeom>
+          <a:noFill/>
+        </p:spPr>
+        <p:txBody>
+          <a:bodyPr wrap="square" rtlCol="0">
+            <a:spAutoFit/>
+          </a:bodyPr>
+          <a:lstStyle/>
+          <a:p>
+            <a:r>
+              <a:rPr lang="en-US" sz="1200" dirty="0">
+                <a:solidFill>
+                  <a:srgbClr val="00B050"/>
+                </a:solidFill>
+              </a:rPr>
+              <a:t>F clean up mess in D and E</a:t>
+            </a:r>
+            <a:br>
+              <a:rPr lang="en-US" sz="1200" dirty="0">
+                <a:solidFill>
+                  <a:srgbClr val="00B050"/>
+                </a:solidFill>
+              </a:rPr>
+            </a:br>
+            <a:r>
+              <a:rPr lang="en-US" sz="1200" dirty="0">
+                <a:solidFill>
+                  <a:srgbClr val="00B050"/>
+                </a:solidFill>
+              </a:rPr>
+              <a:t>and ready to publish</a:t>
+            </a:r>
+          </a:p>
+        </p:txBody>
+      </p:sp>
+      <p:sp>
+        <p:nvSpPr>
+          <p:cNvPr id="75" name="TextBox 74">
+            <a:extLst>
+              <a:ext uri="{FF2B5EF4-FFF2-40B4-BE49-F238E27FC236}">
+                <a16:creationId xmlns:a16="http://schemas.microsoft.com/office/drawing/2014/main" id="{C438A923-D427-DCE3-4161-4F8801BD0C32}"/>
+              </a:ext>
+            </a:extLst>
+          </p:cNvPr>
+          <p:cNvSpPr txBox="1"/>
+          <p:nvPr/>
+        </p:nvSpPr>
+        <p:spPr>
+          <a:xfrm rot="18973322">
+            <a:off x="5333707" y="3381935"/>
+            <a:ext cx="507831" cy="2723595"/>
+          </a:xfrm>
+          <a:prstGeom prst="rect">
+            <a:avLst/>
+          </a:prstGeom>
+          <a:noFill/>
+        </p:spPr>
+        <p:txBody>
+          <a:bodyPr vert="eaVert" wrap="square" rtlCol="0">
+            <a:spAutoFit/>
+          </a:bodyPr>
+          <a:lstStyle/>
+          <a:p>
+            <a:r>
+              <a:rPr lang="en-US" sz="1050" b="1" dirty="0">
+                <a:solidFill>
+                  <a:schemeClr val="accent1">
+                    <a:lumMod val="60000"/>
+                    <a:lumOff val="40000"/>
+                  </a:schemeClr>
+                </a:solidFill>
+              </a:rPr>
+              <a:t>Regular merge from public to private is OK. Private branch can contain public history.</a:t>
+            </a:r>
+          </a:p>
+        </p:txBody>
+      </p:sp>
+      <p:cxnSp>
+        <p:nvCxnSpPr>
+          <p:cNvPr id="77" name="Straight Arrow Connector 76">
+            <a:extLst>
+              <a:ext uri="{FF2B5EF4-FFF2-40B4-BE49-F238E27FC236}">
+                <a16:creationId xmlns:a16="http://schemas.microsoft.com/office/drawing/2014/main" id="{CE4276CB-66AD-054E-8B29-3D5F6B4A7C35}"/>
+              </a:ext>
+            </a:extLst>
+          </p:cNvPr>
+          <p:cNvCxnSpPr>
+            <a:cxnSpLocks/>
+            <a:stCxn id="146" idx="5"/>
+            <a:endCxn id="106" idx="1"/>
+          </p:cNvCxnSpPr>
+          <p:nvPr/>
+        </p:nvCxnSpPr>
+        <p:spPr>
+          <a:xfrm>
+            <a:off x="8472091" y="3221060"/>
+            <a:ext cx="4024526" cy="3074873"/>
+          </a:xfrm>
+          <a:prstGeom prst="straightConnector1">
+            <a:avLst/>
+          </a:prstGeom>
+          <a:ln>
+            <a:solidFill>
+              <a:srgbClr val="00B0F0"/>
+            </a:solidFill>
+            <a:headEnd type="none" w="med" len="med"/>
+            <a:tailEnd type="arrow" w="med" len="med"/>
+          </a:ln>
+        </p:spPr>
+        <p:style>
+          <a:lnRef idx="3">
+            <a:schemeClr val="accent1"/>
+          </a:lnRef>
+          <a:fillRef idx="0">
+            <a:schemeClr val="accent1"/>
+          </a:fillRef>
+          <a:effectRef idx="2">
+            <a:schemeClr val="accent1"/>
+          </a:effectRef>
+          <a:fontRef idx="minor">
+            <a:schemeClr val="tx1"/>
+          </a:fontRef>
+        </p:style>
+      </p:cxnSp>
+      <p:sp>
+        <p:nvSpPr>
+          <p:cNvPr id="89" name="TextBox 88">
+            <a:extLst>
+              <a:ext uri="{FF2B5EF4-FFF2-40B4-BE49-F238E27FC236}">
+                <a16:creationId xmlns:a16="http://schemas.microsoft.com/office/drawing/2014/main" id="{726D33C4-E3AB-D175-A1E1-9033A422E8A8}"/>
+              </a:ext>
+            </a:extLst>
+          </p:cNvPr>
+          <p:cNvSpPr txBox="1"/>
+          <p:nvPr/>
+        </p:nvSpPr>
+        <p:spPr>
+          <a:xfrm>
+            <a:off x="8413628" y="6216396"/>
+            <a:ext cx="2219373" cy="923330"/>
+          </a:xfrm>
+          <a:prstGeom prst="rect">
+            <a:avLst/>
+          </a:prstGeom>
+          <a:noFill/>
+        </p:spPr>
+        <p:txBody>
+          <a:bodyPr wrap="square" rtlCol="0">
+            <a:spAutoFit/>
+          </a:bodyPr>
+          <a:lstStyle/>
+          <a:p>
+            <a:r>
+              <a:rPr lang="en-US" sz="900" dirty="0">
+                <a:solidFill>
+                  <a:srgbClr val="FF0000"/>
+                </a:solidFill>
+              </a:rPr>
+              <a:t>Delete this feature branch or just stop working on it after squash merge. </a:t>
+            </a:r>
+            <a:r>
+              <a:rPr lang="en-US" sz="900" dirty="0">
+                <a:solidFill>
+                  <a:srgbClr val="FF0000"/>
+                </a:solidFill>
+                <a:highlight>
+                  <a:srgbClr val="FFFF00"/>
+                </a:highlight>
+              </a:rPr>
+              <a:t>Do NOT delete branch if you want to keep this part of the history. Commits without a branch pointer to trace down will go to garbage collection after a month.</a:t>
+            </a:r>
+          </a:p>
+        </p:txBody>
+      </p:sp>
+      <p:sp>
+        <p:nvSpPr>
+          <p:cNvPr id="91" name="Rectangle: Rounded Corners 90">
+            <a:extLst>
+              <a:ext uri="{FF2B5EF4-FFF2-40B4-BE49-F238E27FC236}">
+                <a16:creationId xmlns:a16="http://schemas.microsoft.com/office/drawing/2014/main" id="{8EB722A7-2BF7-9F2A-13CF-E96753D0709D}"/>
+              </a:ext>
+            </a:extLst>
+          </p:cNvPr>
+          <p:cNvSpPr/>
+          <p:nvPr/>
+        </p:nvSpPr>
+        <p:spPr>
+          <a:xfrm>
+            <a:off x="11720386" y="4201800"/>
+            <a:ext cx="2943842" cy="926524"/>
+          </a:xfrm>
+          <a:prstGeom prst="roundRect">
+            <a:avLst/>
+          </a:prstGeom>
+          <a:solidFill>
+            <a:schemeClr val="accent6">
+              <a:alpha val="50000"/>
+            </a:schemeClr>
+          </a:solidFill>
+          <a:ln>
+            <a:noFill/>
+          </a:ln>
+        </p:spPr>
+        <p:style>
+          <a:lnRef idx="0">
+            <a:scrgbClr r="0" g="0" b="0"/>
+          </a:lnRef>
+          <a:fillRef idx="0">
+            <a:scrgbClr r="0" g="0" b="0"/>
+          </a:fillRef>
+          <a:effectRef idx="0">
+            <a:scrgbClr r="0" g="0" b="0"/>
+          </a:effectRef>
+          <a:fontRef idx="minor">
+            <a:schemeClr val="lt1"/>
+          </a:fontRef>
+        </p:style>
+        <p:txBody>
+          <a:bodyPr rtlCol="0" anchor="ctr"/>
+          <a:lstStyle/>
+          <a:p>
+            <a:pPr algn="ctr"/>
+            <a:r>
+              <a:rPr lang="en-US" dirty="0"/>
+              <a:t>Most simplified workflow. Recommended.</a:t>
+            </a:r>
+          </a:p>
+        </p:txBody>
+      </p:sp>
+    </p:spTree>
+    <p:extLst>
+      <p:ext uri="{BB962C8B-B14F-4D97-AF65-F5344CB8AC3E}">
+        <p14:creationId xmlns:p14="http://schemas.microsoft.com/office/powerpoint/2010/main" val="1707951516"/>
+      </p:ext>
+    </p:extLst>
+  </p:cSld>
+  <p:clrMapOvr>
+    <a:masterClrMapping/>
+  </p:clrMapOvr>
+</p:sld>
+</file>
+
+<file path=ppt/slides/slide4.xml><?xml version="1.0" encoding="utf-8"?>
+<p:sld xmlns:a="http://schemas.openxmlformats.org/drawingml/2006/main" xmlns:r="http://schemas.openxmlformats.org/officeDocument/2006/relationships" xmlns:p="http://schemas.openxmlformats.org/presentationml/2006/main">
+  <p:cSld>
+    <p:spTree>
+      <p:nvGrpSpPr>
+        <p:cNvPr id="1" name="">
+          <a:extLst>
+            <a:ext uri="{FF2B5EF4-FFF2-40B4-BE49-F238E27FC236}">
+              <a16:creationId xmlns:a16="http://schemas.microsoft.com/office/drawing/2014/main" id="{2E5AFF46-3A6B-19E0-27F5-ECE4EBF3A74A}"/>
+            </a:ext>
+          </a:extLst>
+        </p:cNvPr>
+        <p:cNvGrpSpPr/>
+        <p:nvPr/>
+      </p:nvGrpSpPr>
+      <p:grpSpPr>
+        <a:xfrm>
+          <a:off x="0" y="0"/>
+          <a:ext cx="0" cy="0"/>
+          <a:chOff x="0" y="0"/>
+          <a:chExt cx="0" cy="0"/>
+        </a:xfrm>
+      </p:grpSpPr>
+      <p:pic>
+        <p:nvPicPr>
+          <p:cNvPr id="9" name="Picture 8">
+            <a:extLst>
+              <a:ext uri="{FF2B5EF4-FFF2-40B4-BE49-F238E27FC236}">
+                <a16:creationId xmlns:a16="http://schemas.microsoft.com/office/drawing/2014/main" id="{1E6D1B7E-87F7-A406-2036-CB6FB216C375}"/>
+              </a:ext>
+            </a:extLst>
+          </p:cNvPr>
+          <p:cNvPicPr>
+            <a:picLocks noChangeAspect="1"/>
+          </p:cNvPicPr>
+          <p:nvPr/>
+        </p:nvPicPr>
+        <p:blipFill>
+          <a:blip r:embed="rId2"/>
+          <a:stretch>
+            <a:fillRect/>
+          </a:stretch>
+        </p:blipFill>
+        <p:spPr>
+          <a:xfrm>
+            <a:off x="278882" y="260313"/>
+            <a:ext cx="6432367" cy="8343973"/>
+          </a:xfrm>
+          <a:prstGeom prst="rect">
+            <a:avLst/>
+          </a:prstGeom>
+          <a:solidFill>
+            <a:srgbClr val="FFFFFF">
+              <a:shade val="85000"/>
+            </a:srgbClr>
+          </a:solidFill>
+          <a:ln w="88900" cap="sq">
+            <a:solidFill>
+              <a:srgbClr val="FFFFFF"/>
+            </a:solidFill>
+            <a:miter lim="800000"/>
+          </a:ln>
+          <a:effectLst>
+            <a:outerShdw blurRad="55000" dist="18000" dir="5400000" algn="tl" rotWithShape="0">
+              <a:srgbClr val="000000">
+                <a:alpha val="40000"/>
+              </a:srgbClr>
+            </a:outerShdw>
+          </a:effectLst>
+          <a:scene3d>
+            <a:camera prst="orthographicFront"/>
+            <a:lightRig rig="twoPt" dir="t">
+              <a:rot lat="0" lon="0" rev="7200000"/>
+            </a:lightRig>
+          </a:scene3d>
+          <a:sp3d>
+            <a:bevelT w="25400" h="19050"/>
+            <a:contourClr>
+              <a:srgbClr val="FFFFFF"/>
+            </a:contourClr>
+          </a:sp3d>
+        </p:spPr>
+      </p:pic>
+    </p:spTree>
+    <p:extLst>
+      <p:ext uri="{BB962C8B-B14F-4D97-AF65-F5344CB8AC3E}">
+        <p14:creationId xmlns:p14="http://schemas.microsoft.com/office/powerpoint/2010/main" val="2108951930"/>
+      </p:ext>
+    </p:extLst>
+  </p:cSld>
+  <p:clrMapOvr>
+    <a:masterClrMapping/>
+  </p:clrMapOvr>
+</p:sld>
+</file>
+
+<file path=ppt/slides/slide5.xml><?xml version="1.0" encoding="utf-8"?>
 <p:sld xmlns:a="http://schemas.openxmlformats.org/drawingml/2006/main" xmlns:r="http://schemas.openxmlformats.org/officeDocument/2006/relationships" xmlns:p="http://schemas.openxmlformats.org/presentationml/2006/main">
   <p:cSld>
     <p:spTree>
@@ -7152,66 +11478,126 @@
           </a:sp3d>
         </p:spPr>
       </p:pic>
-      <p:pic>
-        <p:nvPicPr>
-          <p:cNvPr id="7" name="Picture 6">
+      <p:grpSp>
+        <p:nvGrpSpPr>
+          <p:cNvPr id="3" name="Group 2">
             <a:extLst>
               <a:ext uri="{FF2B5EF4-FFF2-40B4-BE49-F238E27FC236}">
-                <a16:creationId xmlns:a16="http://schemas.microsoft.com/office/drawing/2014/main" id="{0B80E33E-1216-C80E-4D88-F6E82E49EF3E}"/>
+                <a16:creationId xmlns:a16="http://schemas.microsoft.com/office/drawing/2014/main" id="{B709DDD5-5EC1-9183-67D3-28249C6F68F4}"/>
               </a:ext>
             </a:extLst>
           </p:cNvPr>
-          <p:cNvPicPr>
-            <a:picLocks noChangeAspect="1"/>
-          </p:cNvPicPr>
+          <p:cNvGrpSpPr/>
           <p:nvPr/>
-        </p:nvPicPr>
-        <p:blipFill>
-          <a:blip r:embed="rId3"/>
-          <a:stretch>
-            <a:fillRect/>
-          </a:stretch>
-        </p:blipFill>
-        <p:spPr>
+        </p:nvGrpSpPr>
+        <p:grpSpPr>
           <a:xfrm>
-            <a:off x="7990012" y="475013"/>
-            <a:ext cx="7736414" cy="8486106"/>
-          </a:xfrm>
-          <a:prstGeom prst="rect">
-            <a:avLst/>
-          </a:prstGeom>
-          <a:solidFill>
-            <a:srgbClr val="FFFFFF">
-              <a:shade val="85000"/>
-            </a:srgbClr>
-          </a:solidFill>
-          <a:ln w="88900" cap="sq">
+            <a:off x="8980743" y="7160029"/>
+            <a:ext cx="2141686" cy="1552500"/>
+            <a:chOff x="7923510" y="462346"/>
+            <a:chExt cx="7736414" cy="8486106"/>
+          </a:xfrm>
+        </p:grpSpPr>
+        <p:pic>
+          <p:nvPicPr>
+            <p:cNvPr id="7" name="Picture 6">
+              <a:extLst>
+                <a:ext uri="{FF2B5EF4-FFF2-40B4-BE49-F238E27FC236}">
+                  <a16:creationId xmlns:a16="http://schemas.microsoft.com/office/drawing/2014/main" id="{0B80E33E-1216-C80E-4D88-F6E82E49EF3E}"/>
+                </a:ext>
+              </a:extLst>
+            </p:cNvPr>
+            <p:cNvPicPr>
+              <a:picLocks noChangeAspect="1"/>
+            </p:cNvPicPr>
+            <p:nvPr/>
+          </p:nvPicPr>
+          <p:blipFill>
+            <a:blip r:embed="rId3"/>
+            <a:stretch>
+              <a:fillRect/>
+            </a:stretch>
+          </p:blipFill>
+          <p:spPr>
+            <a:xfrm>
+              <a:off x="7923510" y="462346"/>
+              <a:ext cx="7736414" cy="8486106"/>
+            </a:xfrm>
+            <a:prstGeom prst="rect">
+              <a:avLst/>
+            </a:prstGeom>
             <a:solidFill>
-              <a:srgbClr val="FFFFFF"/>
+              <a:srgbClr val="FFFFFF">
+                <a:shade val="85000"/>
+              </a:srgbClr>
             </a:solidFill>
-            <a:miter lim="800000"/>
-          </a:ln>
-          <a:effectLst>
-            <a:outerShdw blurRad="55000" dist="18000" dir="5400000" algn="tl" rotWithShape="0">
-              <a:srgbClr val="000000">
-                <a:alpha val="40000"/>
-              </a:srgbClr>
-            </a:outerShdw>
-          </a:effectLst>
-          <a:scene3d>
-            <a:camera prst="orthographicFront"/>
-            <a:lightRig rig="twoPt" dir="t">
-              <a:rot lat="0" lon="0" rev="7200000"/>
-            </a:lightRig>
-          </a:scene3d>
-          <a:sp3d>
-            <a:bevelT w="25400" h="19050"/>
-            <a:contourClr>
-              <a:srgbClr val="FFFFFF"/>
-            </a:contourClr>
-          </a:sp3d>
-        </p:spPr>
-      </p:pic>
+            <a:ln w="88900" cap="sq">
+              <a:solidFill>
+                <a:srgbClr val="FFFFFF"/>
+              </a:solidFill>
+              <a:miter lim="800000"/>
+            </a:ln>
+            <a:effectLst>
+              <a:outerShdw blurRad="55000" dist="18000" dir="5400000" algn="tl" rotWithShape="0">
+                <a:srgbClr val="000000">
+                  <a:alpha val="40000"/>
+                </a:srgbClr>
+              </a:outerShdw>
+            </a:effectLst>
+            <a:scene3d>
+              <a:camera prst="orthographicFront"/>
+              <a:lightRig rig="twoPt" dir="t">
+                <a:rot lat="0" lon="0" rev="7200000"/>
+              </a:lightRig>
+            </a:scene3d>
+            <a:sp3d>
+              <a:bevelT w="25400" h="19050"/>
+              <a:contourClr>
+                <a:srgbClr val="FFFFFF"/>
+              </a:contourClr>
+            </a:sp3d>
+          </p:spPr>
+        </p:pic>
+        <p:sp>
+          <p:nvSpPr>
+            <p:cNvPr id="2" name="TextBox 1">
+              <a:extLst>
+                <a:ext uri="{FF2B5EF4-FFF2-40B4-BE49-F238E27FC236}">
+                  <a16:creationId xmlns:a16="http://schemas.microsoft.com/office/drawing/2014/main" id="{1A819FE5-0CE9-3A46-C09E-BA13A997E7FB}"/>
+                </a:ext>
+              </a:extLst>
+            </p:cNvPr>
+            <p:cNvSpPr txBox="1"/>
+            <p:nvPr/>
+          </p:nvSpPr>
+          <p:spPr>
+            <a:xfrm>
+              <a:off x="13195069" y="462346"/>
+              <a:ext cx="775854" cy="276999"/>
+            </a:xfrm>
+            <a:prstGeom prst="rect">
+              <a:avLst/>
+            </a:prstGeom>
+            <a:noFill/>
+          </p:spPr>
+          <p:txBody>
+            <a:bodyPr wrap="square" rtlCol="0">
+              <a:spAutoFit/>
+            </a:bodyPr>
+            <a:lstStyle/>
+            <a:p>
+              <a:r>
+                <a:rPr lang="en-US" sz="1200" dirty="0">
+                  <a:solidFill>
+                    <a:srgbClr val="FF0000"/>
+                  </a:solidFill>
+                </a:rPr>
+                <a:t>one</a:t>
+              </a:r>
+            </a:p>
+          </p:txBody>
+        </p:sp>
+      </p:grpSp>
     </p:spTree>
     <p:extLst>
       <p:ext uri="{BB962C8B-B14F-4D97-AF65-F5344CB8AC3E}">

</xml_diff>